<commit_message>
Full corpus update: content edits, BSP→FBC rename, header standardization, PDF rebuild
- Apply 30+ session edits: AFRICOM refs, MCIS designation, DA Civilians,
  multi-enclave login, governance chain ordering, Army capitalization,
  Forward (not BLUF), paragraph formatting, MSC units, DIU talking points
- Complete BSP → Foundry Bootcamp rename (dirs, SOP, orphan cleanup)
- Standardize all TM section 1-1 headers to document-type titles
- Remove UNCLASSIFIED classification markings from HTML/scripts/README
- Add alembic migration infrastructure, apps/shared/, check_html_react_sync.py
- Add generate_exercise_data.py, capacity_graph.py
- Rebuild all 189 PDFs from updated markdown source
- Exercise dir renames (EX-40N→EX_40N, EX-50N→EX_50N, etc.)
- Update apps, portal, theme, launcher, tests, dep map, CI pipeline

Co-Authored-By: Claude Opus 4.6 <noreply@anthropic.com>
</commit_message>
<xml_diff>
--- a/maven_training/training_management/MSS_TRAINING_BRIEF.pptx
+++ b/maven_training/training_management/MSS_TRAINING_BRIEF.pptx
@@ -13,6 +13,7 @@
   </p:handoutMasterIdLst>
   <p:sldIdLst>
     <p:sldId id="266" r:id="rId8"/>
+    <p:sldId id="267" r:id="rId7"/>
   </p:sldIdLst>
   <p:sldSz cx="12192000" cy="6858000"/>
   <p:notesSz cx="7010400" cy="9296400"/>
@@ -2576,7 +2577,7 @@
 </file>
 
 <file path=ppt/slides/slide2.xml><?xml version="1.0" encoding="utf-8"?>
-<p:sld xmlns:a="http://schemas.openxmlformats.org/drawingml/2006/main" xmlns:r="http://schemas.openxmlformats.org/officeDocument/2006/relationships" xmlns:p="http://schemas.openxmlformats.org/presentationml/2006/main">
+<p:sld xmlns:a="http://schemas.openxmlformats.org/drawingml/2006/main" xmlns:p="http://schemas.openxmlformats.org/presentationml/2006/main" xmlns:r="http://schemas.openxmlformats.org/officeDocument/2006/relationships">
   <p:cSld>
     <p:spTree>
       <p:nvGrpSpPr>
@@ -2584,2940 +2585,74 @@
         <p:cNvGrpSpPr/>
         <p:nvPr/>
       </p:nvGrpSpPr>
-      <p:grpSpPr>
-        <a:xfrm>
-          <a:off x="0" y="0"/>
-          <a:ext cx="0" cy="0"/>
-          <a:chOff x="0" y="0"/>
-          <a:chExt cx="0" cy="0"/>
-        </a:xfrm>
-      </p:grpSpPr>
-      <p:sp>
-        <p:nvSpPr>
-          <p:cNvPr id="3" name="TextBox 2">
-            <a:extLst>
-              <a:ext uri="{FF2B5EF4-FFF2-40B4-BE49-F238E27FC236}">
-                <a16:creationId xmlns:a16="http://schemas.microsoft.com/office/drawing/2014/main" id="{8E715E04-BA43-421C-27BE-4D6053801C15}"/>
-              </a:ext>
-            </a:extLst>
-          </p:cNvPr>
-          <p:cNvSpPr txBox="1"/>
+      <p:grpSpPr/>
+      <p:pic>
+        <p:nvPicPr>
+          <p:cNvPr id="2" name="Picture 1" descr="capacity_projection.png"/>
+          <p:cNvPicPr>
+            <a:picLocks noChangeAspect="1"/>
+          </p:cNvPicPr>
           <p:nvPr/>
-        </p:nvSpPr>
+        </p:nvPicPr>
+        <p:blipFill>
+          <a:blip r:embed="rId2"/>
+          <a:stretch>
+            <a:fillRect/>
+          </a:stretch>
+        </p:blipFill>
         <p:spPr>
           <a:xfrm>
-            <a:off x="1062990" y="208526"/>
-            <a:ext cx="6094476" cy="369332"/>
+            <a:off x="447443" y="731520"/>
+            <a:ext cx="11294065" cy="5852160"/>
           </a:xfrm>
           <a:prstGeom prst="rect">
             <a:avLst/>
           </a:prstGeom>
-          <a:noFill/>
         </p:spPr>
-        <p:txBody>
-          <a:bodyPr wrap="square">
-            <a:spAutoFit/>
-          </a:bodyPr>
-          <a:lstStyle/>
-          <a:p>
-            <a:pPr algn="l"/>
-            <a:r>
-              <a:rPr sz="1500" b="1">
-                <a:solidFill>
-                  <a:srgbClr val="17325C"/>
-                </a:solidFill>
-              </a:rPr>
-              <a:t>MSS TRAINING PROGRAM — USAREUR-AF</a:t>
-            </a:r>
-            <a:endParaRPr lang="en-CA" sz="1400" dirty="0">
-              <a:latin typeface="Arial" panose="020B0604020202020204" pitchFamily="34" charset="0"/>
-              <a:cs typeface="Arial" panose="020B0604020202020204" pitchFamily="34" charset="0"/>
-            </a:endParaRPr>
-          </a:p>
-        </p:txBody>
-      </p:sp>
-      <p:sp>
-        <p:nvSpPr>
-          <p:cNvPr id="2" name="hlSlideMaster.BlankHeader" descr="CLASSIFICATION: UNCLASSIFIED//REL TO CAN, NATO">
-            <a:extLst>
-              <a:ext uri="{FF2B5EF4-FFF2-40B4-BE49-F238E27FC236}">
-                <a16:creationId xmlns:a16="http://schemas.microsoft.com/office/drawing/2014/main" id="{29BF3DA0-AD4D-B0FA-DC24-FE551C0CC702}"/>
-              </a:ext>
-            </a:extLst>
-          </p:cNvPr>
-          <p:cNvSpPr txBox="1"/>
+      </p:pic>
+    </p:spTree>
+  </p:cSld>
+  <p:clrMapOvr>
+    <a:masterClrMapping/>
+  </p:clrMapOvr>
+</p:sld>
+</file>
+
+<file path=ppt/slides/slide2.xml><?xml version="1.0" encoding="utf-8"?>
+<p:sld xmlns:a="http://schemas.openxmlformats.org/drawingml/2006/main" xmlns:p="http://schemas.openxmlformats.org/presentationml/2006/main" xmlns:r="http://schemas.openxmlformats.org/officeDocument/2006/relationships">
+  <p:cSld>
+    <p:spTree>
+      <p:nvGrpSpPr>
+        <p:cNvPr id="1" name=""/>
+        <p:cNvGrpSpPr/>
+        <p:nvPr/>
+      </p:nvGrpSpPr>
+      <p:grpSpPr/>
+      <p:pic>
+        <p:nvPicPr>
+          <p:cNvPr id="2" name="Picture 1" descr="capacity_projection.png"/>
+          <p:cNvPicPr>
+            <a:picLocks noChangeAspect="1"/>
+          </p:cNvPicPr>
           <p:nvPr/>
-        </p:nvSpPr>
+        </p:nvPicPr>
+        <p:blipFill>
+          <a:blip r:embed="rId2"/>
+          <a:stretch>
+            <a:fillRect/>
+          </a:stretch>
+        </p:blipFill>
         <p:spPr>
           <a:xfrm>
-            <a:off x="0" y="0"/>
-            <a:ext cx="12192000" cy="230832"/>
+            <a:off x="447443" y="731520"/>
+            <a:ext cx="11294065" cy="5852160"/>
           </a:xfrm>
           <a:prstGeom prst="rect">
             <a:avLst/>
           </a:prstGeom>
-          <a:noFill/>
         </p:spPr>
-        <p:txBody>
-          <a:bodyPr vert="horz" rtlCol="0">
-            <a:spAutoFit/>
-          </a:bodyPr>
-          <a:lstStyle/>
-          <a:p>
-            <a:pPr algn="ctr"/>
-            <a:r>
-              <a:rPr lang="en-CA" sz="900" b="1" i="0" u="none" baseline="0" dirty="0">
-                <a:solidFill>
-                  <a:srgbClr val="7030A0"/>
-                </a:solidFill>
-                <a:latin typeface="Arial" panose="020B0604020202020204" pitchFamily="34" charset="0"/>
-                <a:cs typeface="Arial" panose="020B0604020202020204" pitchFamily="34" charset="0"/>
-              </a:rPr>
-              <a:t>UNCLASSIFIED</a:t>
-            </a:r>
-          </a:p>
-        </p:txBody>
-      </p:sp>
-      <p:sp>
-        <p:nvSpPr>
-          <p:cNvPr id="8" name="TextBox 7"/>
-          <p:cNvSpPr txBox="1"/>
-          <p:nvPr/>
-        </p:nvSpPr>
-        <p:spPr>
-          <a:xfrm>
-            <a:off x="0" y="6629400"/>
-            <a:ext cx="12188952" cy="228600"/>
-          </a:xfrm>
-          <a:prstGeom prst="rect">
-            <a:avLst/>
-          </a:prstGeom>
-          <a:noFill/>
-        </p:spPr>
-        <p:txBody>
-          <a:bodyPr wrap="none">
-            <a:spAutoFit/>
-          </a:bodyPr>
-          <a:lstStyle/>
-          <a:p>
-            <a:pPr algn="ctr"/>
-            <a:r>
-              <a:rPr sz="900" b="1">
-                <a:solidFill>
-                  <a:srgbClr val="7030A0"/>
-                </a:solidFill>
-              </a:rPr>
-              <a:t>UNCLASSIFIED</a:t>
-            </a:r>
-          </a:p>
-        </p:txBody>
-      </p:sp>
-      <p:sp>
-        <p:nvSpPr>
-          <p:cNvPr id="9" name="TextBox 8"/>
-          <p:cNvSpPr txBox="1"/>
-          <p:nvPr/>
-        </p:nvSpPr>
-        <p:spPr>
-          <a:xfrm>
-            <a:off x="1060704" y="640080"/>
-            <a:ext cx="11000232" cy="182880"/>
-          </a:xfrm>
-          <a:prstGeom prst="rect">
-            <a:avLst/>
-          </a:prstGeom>
-          <a:noFill/>
-        </p:spPr>
-        <p:txBody>
-          <a:bodyPr wrap="square">
-            <a:spAutoFit/>
-          </a:bodyPr>
-          <a:lstStyle/>
-          <a:p>
-            <a:pPr algn="l"/>
-            <a:r>
-              <a:rPr sz="850" b="0" i="1">
-                <a:solidFill>
-                  <a:srgbClr val="888888"/>
-                </a:solidFill>
-              </a:rPr>
-              <a:t>Operator training path  ·  prereq chain: TM-10 → TM-20 → TM-30  ·  BSP: quarterly parallel build sprint (dashed = not in prereq chain)</a:t>
-            </a:r>
-          </a:p>
-        </p:txBody>
-      </p:sp>
-      <p:sp>
-        <p:nvSpPr>
-          <p:cNvPr id="10" name="Rectangle 9"/>
-          <p:cNvSpPr/>
-          <p:nvPr/>
-        </p:nvSpPr>
-        <p:spPr>
-          <a:xfrm>
-            <a:off x="320040" y="896112"/>
-            <a:ext cx="2194560" cy="1097280"/>
-          </a:xfrm>
-          <a:prstGeom prst="rect">
-            <a:avLst/>
-          </a:prstGeom>
-          <a:solidFill>
-            <a:srgbClr val="1F3864"/>
-          </a:solidFill>
-          <a:ln w="9525">
-            <a:solidFill>
-              <a:srgbClr val="FFFFFF"/>
-            </a:solidFill>
-          </a:ln>
-        </p:spPr>
-        <p:style>
-          <a:lnRef idx="1">
-            <a:schemeClr val="accent1"/>
-          </a:lnRef>
-          <a:fillRef idx="3">
-            <a:schemeClr val="accent1"/>
-          </a:fillRef>
-          <a:effectRef idx="2">
-            <a:schemeClr val="accent1"/>
-          </a:effectRef>
-          <a:fontRef idx="minor">
-            <a:schemeClr val="lt1"/>
-          </a:fontRef>
-        </p:style>
-        <p:txBody>
-          <a:bodyPr rtlCol="0" anchor="ctr"/>
-          <a:lstStyle/>
-          <a:p>
-            <a:pPr algn="ctr"/>
-          </a:p>
-        </p:txBody>
-      </p:sp>
-      <p:sp>
-        <p:nvSpPr>
-          <p:cNvPr id="11" name="TextBox 10"/>
-          <p:cNvSpPr txBox="1"/>
-          <p:nvPr/>
-        </p:nvSpPr>
-        <p:spPr>
-          <a:xfrm>
-            <a:off x="438912" y="960120"/>
-            <a:ext cx="1956816" cy="310896"/>
-          </a:xfrm>
-          <a:prstGeom prst="rect">
-            <a:avLst/>
-          </a:prstGeom>
-          <a:noFill/>
-        </p:spPr>
-        <p:txBody>
-          <a:bodyPr wrap="square">
-            <a:spAutoFit/>
-          </a:bodyPr>
-          <a:lstStyle/>
-          <a:p>
-            <a:pPr algn="l"/>
-            <a:r>
-              <a:rPr sz="2200" b="1" i="0">
-                <a:solidFill>
-                  <a:srgbClr val="FFFFFF"/>
-                </a:solidFill>
-              </a:rPr>
-              <a:t>TM-10</a:t>
-            </a:r>
-          </a:p>
-        </p:txBody>
-      </p:sp>
-      <p:sp>
-        <p:nvSpPr>
-          <p:cNvPr id="12" name="TextBox 11"/>
-          <p:cNvSpPr txBox="1"/>
-          <p:nvPr/>
-        </p:nvSpPr>
-        <p:spPr>
-          <a:xfrm>
-            <a:off x="438912" y="1261872"/>
-            <a:ext cx="1956816" cy="201168"/>
-          </a:xfrm>
-          <a:prstGeom prst="rect">
-            <a:avLst/>
-          </a:prstGeom>
-          <a:noFill/>
-        </p:spPr>
-        <p:txBody>
-          <a:bodyPr wrap="square">
-            <a:spAutoFit/>
-          </a:bodyPr>
-          <a:lstStyle/>
-          <a:p>
-            <a:pPr algn="l"/>
-            <a:r>
-              <a:rPr sz="1000" b="1" i="0">
-                <a:solidFill>
-                  <a:srgbClr val="C9A84C"/>
-                </a:solidFill>
-              </a:rPr>
-              <a:t>MAVEN USER</a:t>
-            </a:r>
-          </a:p>
-        </p:txBody>
-      </p:sp>
-      <p:sp>
-        <p:nvSpPr>
-          <p:cNvPr id="13" name="TextBox 12"/>
-          <p:cNvSpPr txBox="1"/>
-          <p:nvPr/>
-        </p:nvSpPr>
-        <p:spPr>
-          <a:xfrm>
-            <a:off x="438912" y="1463040"/>
-            <a:ext cx="1956816" cy="182880"/>
-          </a:xfrm>
-          <a:prstGeom prst="rect">
-            <a:avLst/>
-          </a:prstGeom>
-          <a:noFill/>
-        </p:spPr>
-        <p:txBody>
-          <a:bodyPr wrap="square">
-            <a:spAutoFit/>
-          </a:bodyPr>
-          <a:lstStyle/>
-          <a:p>
-            <a:pPr algn="l"/>
-            <a:r>
-              <a:rPr sz="950" b="0" i="0">
-                <a:solidFill>
-                  <a:srgbClr val="FFFFFF"/>
-                </a:solidFill>
-              </a:rPr>
-              <a:t>8 hrs  ·  All Personnel</a:t>
-            </a:r>
-          </a:p>
-        </p:txBody>
-      </p:sp>
-      <p:sp>
-        <p:nvSpPr>
-          <p:cNvPr id="14" name="TextBox 13"/>
-          <p:cNvSpPr txBox="1"/>
-          <p:nvPr/>
-        </p:nvSpPr>
-        <p:spPr>
-          <a:xfrm>
-            <a:off x="438912" y="1664208"/>
-            <a:ext cx="1956816" cy="182880"/>
-          </a:xfrm>
-          <a:prstGeom prst="rect">
-            <a:avLst/>
-          </a:prstGeom>
-          <a:noFill/>
-        </p:spPr>
-        <p:txBody>
-          <a:bodyPr wrap="square">
-            <a:spAutoFit/>
-          </a:bodyPr>
-          <a:lstStyle/>
-          <a:p>
-            <a:pPr algn="l"/>
-            <a:r>
-              <a:rPr sz="850" b="0" i="1">
-                <a:solidFill>
-                  <a:srgbClr val="CCDDFF"/>
-                </a:solidFill>
-              </a:rPr>
-              <a:t>No prereq  ·  New soldier in-processing</a:t>
-            </a:r>
-          </a:p>
-        </p:txBody>
-      </p:sp>
-      <p:sp>
-        <p:nvSpPr>
-          <p:cNvPr id="15" name="Rectangle 14"/>
-          <p:cNvSpPr/>
-          <p:nvPr/>
-        </p:nvSpPr>
-        <p:spPr>
-          <a:xfrm>
-            <a:off x="2542032" y="1408176"/>
-            <a:ext cx="100584" cy="73152"/>
-          </a:xfrm>
-          <a:prstGeom prst="rect">
-            <a:avLst/>
-          </a:prstGeom>
-          <a:solidFill>
-            <a:srgbClr val="C9A84C"/>
-          </a:solidFill>
-          <a:ln>
-            <a:noFill/>
-          </a:ln>
-        </p:spPr>
-        <p:style>
-          <a:lnRef idx="1">
-            <a:schemeClr val="accent1"/>
-          </a:lnRef>
-          <a:fillRef idx="3">
-            <a:schemeClr val="accent1"/>
-          </a:fillRef>
-          <a:effectRef idx="2">
-            <a:schemeClr val="accent1"/>
-          </a:effectRef>
-          <a:fontRef idx="minor">
-            <a:schemeClr val="lt1"/>
-          </a:fontRef>
-        </p:style>
-        <p:txBody>
-          <a:bodyPr rtlCol="0" anchor="ctr"/>
-          <a:lstStyle/>
-          <a:p>
-            <a:pPr algn="ctr"/>
-          </a:p>
-        </p:txBody>
-      </p:sp>
-      <p:sp>
-        <p:nvSpPr>
-          <p:cNvPr id="16" name="Can 15"/>
-          <p:cNvSpPr/>
-          <p:nvPr/>
-        </p:nvSpPr>
-        <p:spPr>
-          <a:xfrm>
-            <a:off x="2551176" y="1325880"/>
-            <a:ext cx="118872" cy="237744"/>
-          </a:xfrm>
-          <a:prstGeom prst="can">
-            <a:avLst/>
-          </a:prstGeom>
-          <a:solidFill>
-            <a:srgbClr val="C9A84C"/>
-          </a:solidFill>
-          <a:ln>
-            <a:noFill/>
-          </a:ln>
-        </p:spPr>
-        <p:style>
-          <a:lnRef idx="1">
-            <a:schemeClr val="accent1"/>
-          </a:lnRef>
-          <a:fillRef idx="3">
-            <a:schemeClr val="accent1"/>
-          </a:fillRef>
-          <a:effectRef idx="2">
-            <a:schemeClr val="accent1"/>
-          </a:effectRef>
-          <a:fontRef idx="minor">
-            <a:schemeClr val="lt1"/>
-          </a:fontRef>
-        </p:style>
-        <p:txBody>
-          <a:bodyPr rtlCol="0" anchor="ctr"/>
-          <a:lstStyle/>
-          <a:p>
-            <a:pPr algn="ctr"/>
-          </a:p>
-        </p:txBody>
-      </p:sp>
-      <p:sp>
-        <p:nvSpPr>
-          <p:cNvPr id="17" name="Rectangle 16"/>
-          <p:cNvSpPr/>
-          <p:nvPr/>
-        </p:nvSpPr>
-        <p:spPr>
-          <a:xfrm>
-            <a:off x="2670048" y="896112"/>
-            <a:ext cx="2011680" cy="1097280"/>
-          </a:xfrm>
-          <a:prstGeom prst="rect">
-            <a:avLst/>
-          </a:prstGeom>
-          <a:solidFill>
-            <a:srgbClr val="2E4D8A"/>
-          </a:solidFill>
-          <a:ln w="6350">
-            <a:solidFill>
-              <a:srgbClr val="6080C0"/>
-            </a:solidFill>
-          </a:ln>
-        </p:spPr>
-        <p:style>
-          <a:lnRef idx="1">
-            <a:schemeClr val="accent1"/>
-          </a:lnRef>
-          <a:fillRef idx="3">
-            <a:schemeClr val="accent1"/>
-          </a:fillRef>
-          <a:effectRef idx="2">
-            <a:schemeClr val="accent1"/>
-          </a:effectRef>
-          <a:fontRef idx="minor">
-            <a:schemeClr val="lt1"/>
-          </a:fontRef>
-        </p:style>
-        <p:txBody>
-          <a:bodyPr rtlCol="0" anchor="ctr"/>
-          <a:lstStyle/>
-          <a:p>
-            <a:pPr algn="ctr"/>
-          </a:p>
-        </p:txBody>
-      </p:sp>
-      <p:sp>
-        <p:nvSpPr>
-          <p:cNvPr id="18" name="TextBox 17"/>
-          <p:cNvSpPr txBox="1"/>
-          <p:nvPr/>
-        </p:nvSpPr>
-        <p:spPr>
-          <a:xfrm>
-            <a:off x="2761488" y="960120"/>
-            <a:ext cx="1828800" cy="164592"/>
-          </a:xfrm>
-          <a:prstGeom prst="rect">
-            <a:avLst/>
-          </a:prstGeom>
-          <a:noFill/>
-        </p:spPr>
-        <p:txBody>
-          <a:bodyPr wrap="square">
-            <a:spAutoFit/>
-          </a:bodyPr>
-          <a:lstStyle/>
-          <a:p>
-            <a:pPr algn="l"/>
-            <a:r>
-              <a:rPr sz="750" b="1" i="0">
-                <a:solidFill>
-                  <a:srgbClr val="C9A84C"/>
-                </a:solidFill>
-              </a:rPr>
-              <a:t>SYLLABUS</a:t>
-            </a:r>
-          </a:p>
-        </p:txBody>
-      </p:sp>
-      <p:sp>
-        <p:nvSpPr>
-          <p:cNvPr id="19" name="TextBox 18"/>
-          <p:cNvSpPr txBox="1"/>
-          <p:nvPr/>
-        </p:nvSpPr>
-        <p:spPr>
-          <a:xfrm>
-            <a:off x="2761488" y="1152144"/>
-            <a:ext cx="1828800" cy="786384"/>
-          </a:xfrm>
-          <a:prstGeom prst="rect">
-            <a:avLst/>
-          </a:prstGeom>
-          <a:noFill/>
-        </p:spPr>
-        <p:txBody>
-          <a:bodyPr wrap="square">
-            <a:spAutoFit/>
-          </a:bodyPr>
-          <a:lstStyle/>
-          <a:p>
-            <a:pPr algn="l"/>
-            <a:r>
-              <a:rPr sz="950" b="0" i="0">
-                <a:solidFill>
-                  <a:srgbClr val="FFFFFF"/>
-                </a:solidFill>
-              </a:rPr>
-              <a:t>TM-10</a:t>
-            </a:r>
-          </a:p>
-        </p:txBody>
-      </p:sp>
-      <p:sp>
-        <p:nvSpPr>
-          <p:cNvPr id="20" name="Rectangle 19"/>
-          <p:cNvSpPr/>
-          <p:nvPr/>
-        </p:nvSpPr>
-        <p:spPr>
-          <a:xfrm>
-            <a:off x="4709160" y="1408176"/>
-            <a:ext cx="100584" cy="73152"/>
-          </a:xfrm>
-          <a:prstGeom prst="rect">
-            <a:avLst/>
-          </a:prstGeom>
-          <a:solidFill>
-            <a:srgbClr val="C9A84C"/>
-          </a:solidFill>
-          <a:ln>
-            <a:noFill/>
-          </a:ln>
-        </p:spPr>
-        <p:style>
-          <a:lnRef idx="1">
-            <a:schemeClr val="accent1"/>
-          </a:lnRef>
-          <a:fillRef idx="3">
-            <a:schemeClr val="accent1"/>
-          </a:fillRef>
-          <a:effectRef idx="2">
-            <a:schemeClr val="accent1"/>
-          </a:effectRef>
-          <a:fontRef idx="minor">
-            <a:schemeClr val="lt1"/>
-          </a:fontRef>
-        </p:style>
-        <p:txBody>
-          <a:bodyPr rtlCol="0" anchor="ctr"/>
-          <a:lstStyle/>
-          <a:p>
-            <a:pPr algn="ctr"/>
-          </a:p>
-        </p:txBody>
-      </p:sp>
-      <p:sp>
-        <p:nvSpPr>
-          <p:cNvPr id="21" name="Can 20"/>
-          <p:cNvSpPr/>
-          <p:nvPr/>
-        </p:nvSpPr>
-        <p:spPr>
-          <a:xfrm>
-            <a:off x="4718304" y="1325880"/>
-            <a:ext cx="118872" cy="237744"/>
-          </a:xfrm>
-          <a:prstGeom prst="can">
-            <a:avLst/>
-          </a:prstGeom>
-          <a:solidFill>
-            <a:srgbClr val="C9A84C"/>
-          </a:solidFill>
-          <a:ln>
-            <a:noFill/>
-          </a:ln>
-        </p:spPr>
-        <p:style>
-          <a:lnRef idx="1">
-            <a:schemeClr val="accent1"/>
-          </a:lnRef>
-          <a:fillRef idx="3">
-            <a:schemeClr val="accent1"/>
-          </a:fillRef>
-          <a:effectRef idx="2">
-            <a:schemeClr val="accent1"/>
-          </a:effectRef>
-          <a:fontRef idx="minor">
-            <a:schemeClr val="lt1"/>
-          </a:fontRef>
-        </p:style>
-        <p:txBody>
-          <a:bodyPr rtlCol="0" anchor="ctr"/>
-          <a:lstStyle/>
-          <a:p>
-            <a:pPr algn="ctr"/>
-          </a:p>
-        </p:txBody>
-      </p:sp>
-      <p:sp>
-        <p:nvSpPr>
-          <p:cNvPr id="22" name="Rectangle 21"/>
-          <p:cNvSpPr/>
-          <p:nvPr/>
-        </p:nvSpPr>
-        <p:spPr>
-          <a:xfrm>
-            <a:off x="4837176" y="896112"/>
-            <a:ext cx="2011680" cy="1097280"/>
-          </a:xfrm>
-          <a:prstGeom prst="rect">
-            <a:avLst/>
-          </a:prstGeom>
-          <a:solidFill>
-            <a:srgbClr val="2E4D8A"/>
-          </a:solidFill>
-          <a:ln w="6350">
-            <a:solidFill>
-              <a:srgbClr val="6080C0"/>
-            </a:solidFill>
-          </a:ln>
-        </p:spPr>
-        <p:style>
-          <a:lnRef idx="1">
-            <a:schemeClr val="accent1"/>
-          </a:lnRef>
-          <a:fillRef idx="3">
-            <a:schemeClr val="accent1"/>
-          </a:fillRef>
-          <a:effectRef idx="2">
-            <a:schemeClr val="accent1"/>
-          </a:effectRef>
-          <a:fontRef idx="minor">
-            <a:schemeClr val="lt1"/>
-          </a:fontRef>
-        </p:style>
-        <p:txBody>
-          <a:bodyPr rtlCol="0" anchor="ctr"/>
-          <a:lstStyle/>
-          <a:p>
-            <a:pPr algn="ctr"/>
-          </a:p>
-        </p:txBody>
-      </p:sp>
-      <p:sp>
-        <p:nvSpPr>
-          <p:cNvPr id="23" name="TextBox 22"/>
-          <p:cNvSpPr txBox="1"/>
-          <p:nvPr/>
-        </p:nvSpPr>
-        <p:spPr>
-          <a:xfrm>
-            <a:off x="4928616" y="960120"/>
-            <a:ext cx="1828800" cy="164592"/>
-          </a:xfrm>
-          <a:prstGeom prst="rect">
-            <a:avLst/>
-          </a:prstGeom>
-          <a:noFill/>
-        </p:spPr>
-        <p:txBody>
-          <a:bodyPr wrap="square">
-            <a:spAutoFit/>
-          </a:bodyPr>
-          <a:lstStyle/>
-          <a:p>
-            <a:pPr algn="l"/>
-            <a:r>
-              <a:rPr sz="750" b="1" i="0">
-                <a:solidFill>
-                  <a:srgbClr val="C9A84C"/>
-                </a:solidFill>
-              </a:rPr>
-              <a:t>EXERCISE</a:t>
-            </a:r>
-          </a:p>
-        </p:txBody>
-      </p:sp>
-      <p:sp>
-        <p:nvSpPr>
-          <p:cNvPr id="24" name="TextBox 23"/>
-          <p:cNvSpPr txBox="1"/>
-          <p:nvPr/>
-        </p:nvSpPr>
-        <p:spPr>
-          <a:xfrm>
-            <a:off x="4928616" y="1152144"/>
-            <a:ext cx="1828800" cy="786384"/>
-          </a:xfrm>
-          <a:prstGeom prst="rect">
-            <a:avLst/>
-          </a:prstGeom>
-          <a:noFill/>
-        </p:spPr>
-        <p:txBody>
-          <a:bodyPr wrap="square">
-            <a:spAutoFit/>
-          </a:bodyPr>
-          <a:lstStyle/>
-          <a:p>
-            <a:pPr algn="l"/>
-            <a:r>
-              <a:rPr sz="950" b="0" i="0">
-                <a:solidFill>
-                  <a:srgbClr val="FFFFFF"/>
-                </a:solidFill>
-              </a:rPr>
-              <a:t>EX-10  Operator</a:t>
-            </a:r>
-          </a:p>
-        </p:txBody>
-      </p:sp>
-      <p:sp>
-        <p:nvSpPr>
-          <p:cNvPr id="25" name="Rectangle 24"/>
-          <p:cNvSpPr/>
-          <p:nvPr/>
-        </p:nvSpPr>
-        <p:spPr>
-          <a:xfrm>
-            <a:off x="6876288" y="1408176"/>
-            <a:ext cx="100584" cy="73152"/>
-          </a:xfrm>
-          <a:prstGeom prst="rect">
-            <a:avLst/>
-          </a:prstGeom>
-          <a:solidFill>
-            <a:srgbClr val="C9A84C"/>
-          </a:solidFill>
-          <a:ln>
-            <a:noFill/>
-          </a:ln>
-        </p:spPr>
-        <p:style>
-          <a:lnRef idx="1">
-            <a:schemeClr val="accent1"/>
-          </a:lnRef>
-          <a:fillRef idx="3">
-            <a:schemeClr val="accent1"/>
-          </a:fillRef>
-          <a:effectRef idx="2">
-            <a:schemeClr val="accent1"/>
-          </a:effectRef>
-          <a:fontRef idx="minor">
-            <a:schemeClr val="lt1"/>
-          </a:fontRef>
-        </p:style>
-        <p:txBody>
-          <a:bodyPr rtlCol="0" anchor="ctr"/>
-          <a:lstStyle/>
-          <a:p>
-            <a:pPr algn="ctr"/>
-          </a:p>
-        </p:txBody>
-      </p:sp>
-      <p:sp>
-        <p:nvSpPr>
-          <p:cNvPr id="26" name="Can 25"/>
-          <p:cNvSpPr/>
-          <p:nvPr/>
-        </p:nvSpPr>
-        <p:spPr>
-          <a:xfrm>
-            <a:off x="6885432" y="1325880"/>
-            <a:ext cx="118872" cy="237744"/>
-          </a:xfrm>
-          <a:prstGeom prst="can">
-            <a:avLst/>
-          </a:prstGeom>
-          <a:solidFill>
-            <a:srgbClr val="C9A84C"/>
-          </a:solidFill>
-          <a:ln>
-            <a:noFill/>
-          </a:ln>
-        </p:spPr>
-        <p:style>
-          <a:lnRef idx="1">
-            <a:schemeClr val="accent1"/>
-          </a:lnRef>
-          <a:fillRef idx="3">
-            <a:schemeClr val="accent1"/>
-          </a:fillRef>
-          <a:effectRef idx="2">
-            <a:schemeClr val="accent1"/>
-          </a:effectRef>
-          <a:fontRef idx="minor">
-            <a:schemeClr val="lt1"/>
-          </a:fontRef>
-        </p:style>
-        <p:txBody>
-          <a:bodyPr rtlCol="0" anchor="ctr"/>
-          <a:lstStyle/>
-          <a:p>
-            <a:pPr algn="ctr"/>
-          </a:p>
-        </p:txBody>
-      </p:sp>
-      <p:sp>
-        <p:nvSpPr>
-          <p:cNvPr id="27" name="Rectangle 26"/>
-          <p:cNvSpPr/>
-          <p:nvPr/>
-        </p:nvSpPr>
-        <p:spPr>
-          <a:xfrm>
-            <a:off x="7004304" y="896112"/>
-            <a:ext cx="2011680" cy="1097280"/>
-          </a:xfrm>
-          <a:prstGeom prst="rect">
-            <a:avLst/>
-          </a:prstGeom>
-          <a:solidFill>
-            <a:srgbClr val="2E4D8A"/>
-          </a:solidFill>
-          <a:ln w="6350">
-            <a:solidFill>
-              <a:srgbClr val="6080C0"/>
-            </a:solidFill>
-          </a:ln>
-        </p:spPr>
-        <p:style>
-          <a:lnRef idx="1">
-            <a:schemeClr val="accent1"/>
-          </a:lnRef>
-          <a:fillRef idx="3">
-            <a:schemeClr val="accent1"/>
-          </a:fillRef>
-          <a:effectRef idx="2">
-            <a:schemeClr val="accent1"/>
-          </a:effectRef>
-          <a:fontRef idx="minor">
-            <a:schemeClr val="lt1"/>
-          </a:fontRef>
-        </p:style>
-        <p:txBody>
-          <a:bodyPr rtlCol="0" anchor="ctr"/>
-          <a:lstStyle/>
-          <a:p>
-            <a:pPr algn="ctr"/>
-          </a:p>
-        </p:txBody>
-      </p:sp>
-      <p:sp>
-        <p:nvSpPr>
-          <p:cNvPr id="28" name="TextBox 27"/>
-          <p:cNvSpPr txBox="1"/>
-          <p:nvPr/>
-        </p:nvSpPr>
-        <p:spPr>
-          <a:xfrm>
-            <a:off x="7095744" y="960120"/>
-            <a:ext cx="1828800" cy="164592"/>
-          </a:xfrm>
-          <a:prstGeom prst="rect">
-            <a:avLst/>
-          </a:prstGeom>
-          <a:noFill/>
-        </p:spPr>
-        <p:txBody>
-          <a:bodyPr wrap="square">
-            <a:spAutoFit/>
-          </a:bodyPr>
-          <a:lstStyle/>
-          <a:p>
-            <a:pPr algn="l"/>
-            <a:r>
-              <a:rPr sz="750" b="1" i="0">
-                <a:solidFill>
-                  <a:srgbClr val="C9A84C"/>
-                </a:solidFill>
-              </a:rPr>
-              <a:t>EXAMS</a:t>
-            </a:r>
-          </a:p>
-        </p:txBody>
-      </p:sp>
-      <p:sp>
-        <p:nvSpPr>
-          <p:cNvPr id="29" name="TextBox 28"/>
-          <p:cNvSpPr txBox="1"/>
-          <p:nvPr/>
-        </p:nvSpPr>
-        <p:spPr>
-          <a:xfrm>
-            <a:off x="7095744" y="1152144"/>
-            <a:ext cx="1828800" cy="786384"/>
-          </a:xfrm>
-          <a:prstGeom prst="rect">
-            <a:avLst/>
-          </a:prstGeom>
-          <a:noFill/>
-        </p:spPr>
-        <p:txBody>
-          <a:bodyPr wrap="square">
-            <a:spAutoFit/>
-          </a:bodyPr>
-          <a:lstStyle/>
-          <a:p>
-            <a:pPr algn="l"/>
-            <a:r>
-              <a:rPr sz="950" b="0" i="0">
-                <a:solidFill>
-                  <a:srgbClr val="FFFFFF"/>
-                </a:solidFill>
-              </a:rPr>
-              <a:t>Pre-assessment
-Post-assessment</a:t>
-            </a:r>
-          </a:p>
-        </p:txBody>
-      </p:sp>
-      <p:sp>
-        <p:nvSpPr>
-          <p:cNvPr id="30" name="Rectangle 29"/>
-          <p:cNvSpPr/>
-          <p:nvPr/>
-        </p:nvSpPr>
-        <p:spPr>
-          <a:xfrm>
-            <a:off x="1371600" y="1993392"/>
-            <a:ext cx="91440" cy="219456"/>
-          </a:xfrm>
-          <a:prstGeom prst="rect">
-            <a:avLst/>
-          </a:prstGeom>
-          <a:solidFill>
-            <a:srgbClr val="C9A84C"/>
-          </a:solidFill>
-          <a:ln>
-            <a:noFill/>
-          </a:ln>
-        </p:spPr>
-        <p:style>
-          <a:lnRef idx="1">
-            <a:schemeClr val="accent1"/>
-          </a:lnRef>
-          <a:fillRef idx="3">
-            <a:schemeClr val="accent1"/>
-          </a:fillRef>
-          <a:effectRef idx="2">
-            <a:schemeClr val="accent1"/>
-          </a:effectRef>
-          <a:fontRef idx="minor">
-            <a:schemeClr val="lt1"/>
-          </a:fontRef>
-        </p:style>
-        <p:txBody>
-          <a:bodyPr rtlCol="0" anchor="ctr"/>
-          <a:lstStyle/>
-          <a:p>
-            <a:pPr algn="ctr"/>
-          </a:p>
-        </p:txBody>
-      </p:sp>
-      <p:sp>
-        <p:nvSpPr>
-          <p:cNvPr id="31" name="Can 30"/>
-          <p:cNvSpPr/>
-          <p:nvPr/>
-        </p:nvSpPr>
-        <p:spPr>
-          <a:xfrm>
-            <a:off x="1298448" y="2084832"/>
-            <a:ext cx="237744" cy="256032"/>
-          </a:xfrm>
-          <a:prstGeom prst="can">
-            <a:avLst/>
-          </a:prstGeom>
-          <a:solidFill>
-            <a:srgbClr val="C9A84C"/>
-          </a:solidFill>
-          <a:ln>
-            <a:noFill/>
-          </a:ln>
-        </p:spPr>
-        <p:style>
-          <a:lnRef idx="1">
-            <a:schemeClr val="accent1"/>
-          </a:lnRef>
-          <a:fillRef idx="3">
-            <a:schemeClr val="accent1"/>
-          </a:fillRef>
-          <a:effectRef idx="2">
-            <a:schemeClr val="accent1"/>
-          </a:effectRef>
-          <a:fontRef idx="minor">
-            <a:schemeClr val="lt1"/>
-          </a:fontRef>
-        </p:style>
-        <p:txBody>
-          <a:bodyPr rtlCol="0" anchor="ctr"/>
-          <a:lstStyle/>
-          <a:p>
-            <a:pPr algn="ctr"/>
-          </a:p>
-        </p:txBody>
-      </p:sp>
-      <p:sp>
-        <p:nvSpPr>
-          <p:cNvPr id="32" name="Rectangle 31"/>
-          <p:cNvSpPr/>
-          <p:nvPr/>
-        </p:nvSpPr>
-        <p:spPr>
-          <a:xfrm>
-            <a:off x="320040" y="2340864"/>
-            <a:ext cx="2194560" cy="1097280"/>
-          </a:xfrm>
-          <a:prstGeom prst="rect">
-            <a:avLst/>
-          </a:prstGeom>
-          <a:solidFill>
-            <a:srgbClr val="2E4D8A"/>
-          </a:solidFill>
-          <a:ln w="9525">
-            <a:solidFill>
-              <a:srgbClr val="FFFFFF"/>
-            </a:solidFill>
-          </a:ln>
-        </p:spPr>
-        <p:style>
-          <a:lnRef idx="1">
-            <a:schemeClr val="accent1"/>
-          </a:lnRef>
-          <a:fillRef idx="3">
-            <a:schemeClr val="accent1"/>
-          </a:fillRef>
-          <a:effectRef idx="2">
-            <a:schemeClr val="accent1"/>
-          </a:effectRef>
-          <a:fontRef idx="minor">
-            <a:schemeClr val="lt1"/>
-          </a:fontRef>
-        </p:style>
-        <p:txBody>
-          <a:bodyPr rtlCol="0" anchor="ctr"/>
-          <a:lstStyle/>
-          <a:p>
-            <a:pPr algn="ctr"/>
-          </a:p>
-        </p:txBody>
-      </p:sp>
-      <p:sp>
-        <p:nvSpPr>
-          <p:cNvPr id="33" name="TextBox 32"/>
-          <p:cNvSpPr txBox="1"/>
-          <p:nvPr/>
-        </p:nvSpPr>
-        <p:spPr>
-          <a:xfrm>
-            <a:off x="438912" y="2404872"/>
-            <a:ext cx="1956816" cy="310896"/>
-          </a:xfrm>
-          <a:prstGeom prst="rect">
-            <a:avLst/>
-          </a:prstGeom>
-          <a:noFill/>
-        </p:spPr>
-        <p:txBody>
-          <a:bodyPr wrap="square">
-            <a:spAutoFit/>
-          </a:bodyPr>
-          <a:lstStyle/>
-          <a:p>
-            <a:pPr algn="l"/>
-            <a:r>
-              <a:rPr sz="2200" b="1" i="0">
-                <a:solidFill>
-                  <a:srgbClr val="FFFFFF"/>
-                </a:solidFill>
-              </a:rPr>
-              <a:t>TM-20</a:t>
-            </a:r>
-          </a:p>
-        </p:txBody>
-      </p:sp>
-      <p:sp>
-        <p:nvSpPr>
-          <p:cNvPr id="34" name="TextBox 33"/>
-          <p:cNvSpPr txBox="1"/>
-          <p:nvPr/>
-        </p:nvSpPr>
-        <p:spPr>
-          <a:xfrm>
-            <a:off x="438912" y="2706624"/>
-            <a:ext cx="1956816" cy="201168"/>
-          </a:xfrm>
-          <a:prstGeom prst="rect">
-            <a:avLst/>
-          </a:prstGeom>
-          <a:noFill/>
-        </p:spPr>
-        <p:txBody>
-          <a:bodyPr wrap="square">
-            <a:spAutoFit/>
-          </a:bodyPr>
-          <a:lstStyle/>
-          <a:p>
-            <a:pPr algn="l"/>
-            <a:r>
-              <a:rPr sz="1000" b="1" i="0">
-                <a:solidFill>
-                  <a:srgbClr val="C9A84C"/>
-                </a:solidFill>
-              </a:rPr>
-              <a:t>BUILDER</a:t>
-            </a:r>
-          </a:p>
-        </p:txBody>
-      </p:sp>
-      <p:sp>
-        <p:nvSpPr>
-          <p:cNvPr id="35" name="TextBox 34"/>
-          <p:cNvSpPr txBox="1"/>
-          <p:nvPr/>
-        </p:nvSpPr>
-        <p:spPr>
-          <a:xfrm>
-            <a:off x="438912" y="2907792"/>
-            <a:ext cx="1956816" cy="182880"/>
-          </a:xfrm>
-          <a:prstGeom prst="rect">
-            <a:avLst/>
-          </a:prstGeom>
-          <a:noFill/>
-        </p:spPr>
-        <p:txBody>
-          <a:bodyPr wrap="square">
-            <a:spAutoFit/>
-          </a:bodyPr>
-          <a:lstStyle/>
-          <a:p>
-            <a:pPr algn="l"/>
-            <a:r>
-              <a:rPr sz="950" b="0" i="0">
-                <a:solidFill>
-                  <a:srgbClr val="FFFFFF"/>
-                </a:solidFill>
-              </a:rPr>
-              <a:t>40 hrs  ·  Data-Adjacent Staff</a:t>
-            </a:r>
-          </a:p>
-        </p:txBody>
-      </p:sp>
-      <p:sp>
-        <p:nvSpPr>
-          <p:cNvPr id="36" name="TextBox 35"/>
-          <p:cNvSpPr txBox="1"/>
-          <p:nvPr/>
-        </p:nvSpPr>
-        <p:spPr>
-          <a:xfrm>
-            <a:off x="438912" y="3108960"/>
-            <a:ext cx="1956816" cy="182880"/>
-          </a:xfrm>
-          <a:prstGeom prst="rect">
-            <a:avLst/>
-          </a:prstGeom>
-          <a:noFill/>
-        </p:spPr>
-        <p:txBody>
-          <a:bodyPr wrap="square">
-            <a:spAutoFit/>
-          </a:bodyPr>
-          <a:lstStyle/>
-          <a:p>
-            <a:pPr algn="l"/>
-            <a:r>
-              <a:rPr sz="850" b="0" i="1">
-                <a:solidFill>
-                  <a:srgbClr val="CCDDFF"/>
-                </a:solidFill>
-              </a:rPr>
-              <a:t>Prereq: TM-10</a:t>
-            </a:r>
-          </a:p>
-        </p:txBody>
-      </p:sp>
-      <p:sp>
-        <p:nvSpPr>
-          <p:cNvPr id="37" name="Rectangle 36"/>
-          <p:cNvSpPr/>
-          <p:nvPr/>
-        </p:nvSpPr>
-        <p:spPr>
-          <a:xfrm>
-            <a:off x="2542032" y="2852928"/>
-            <a:ext cx="100584" cy="73152"/>
-          </a:xfrm>
-          <a:prstGeom prst="rect">
-            <a:avLst/>
-          </a:prstGeom>
-          <a:solidFill>
-            <a:srgbClr val="C9A84C"/>
-          </a:solidFill>
-          <a:ln>
-            <a:noFill/>
-          </a:ln>
-        </p:spPr>
-        <p:style>
-          <a:lnRef idx="1">
-            <a:schemeClr val="accent1"/>
-          </a:lnRef>
-          <a:fillRef idx="3">
-            <a:schemeClr val="accent1"/>
-          </a:fillRef>
-          <a:effectRef idx="2">
-            <a:schemeClr val="accent1"/>
-          </a:effectRef>
-          <a:fontRef idx="minor">
-            <a:schemeClr val="lt1"/>
-          </a:fontRef>
-        </p:style>
-        <p:txBody>
-          <a:bodyPr rtlCol="0" anchor="ctr"/>
-          <a:lstStyle/>
-          <a:p>
-            <a:pPr algn="ctr"/>
-          </a:p>
-        </p:txBody>
-      </p:sp>
-      <p:sp>
-        <p:nvSpPr>
-          <p:cNvPr id="38" name="Can 37"/>
-          <p:cNvSpPr/>
-          <p:nvPr/>
-        </p:nvSpPr>
-        <p:spPr>
-          <a:xfrm>
-            <a:off x="2551176" y="2770632"/>
-            <a:ext cx="118872" cy="237744"/>
-          </a:xfrm>
-          <a:prstGeom prst="can">
-            <a:avLst/>
-          </a:prstGeom>
-          <a:solidFill>
-            <a:srgbClr val="C9A84C"/>
-          </a:solidFill>
-          <a:ln>
-            <a:noFill/>
-          </a:ln>
-        </p:spPr>
-        <p:style>
-          <a:lnRef idx="1">
-            <a:schemeClr val="accent1"/>
-          </a:lnRef>
-          <a:fillRef idx="3">
-            <a:schemeClr val="accent1"/>
-          </a:fillRef>
-          <a:effectRef idx="2">
-            <a:schemeClr val="accent1"/>
-          </a:effectRef>
-          <a:fontRef idx="minor">
-            <a:schemeClr val="lt1"/>
-          </a:fontRef>
-        </p:style>
-        <p:txBody>
-          <a:bodyPr rtlCol="0" anchor="ctr"/>
-          <a:lstStyle/>
-          <a:p>
-            <a:pPr algn="ctr"/>
-          </a:p>
-        </p:txBody>
-      </p:sp>
-      <p:sp>
-        <p:nvSpPr>
-          <p:cNvPr id="39" name="Rectangle 38"/>
-          <p:cNvSpPr/>
-          <p:nvPr/>
-        </p:nvSpPr>
-        <p:spPr>
-          <a:xfrm>
-            <a:off x="2670048" y="2340864"/>
-            <a:ext cx="2011680" cy="1097280"/>
-          </a:xfrm>
-          <a:prstGeom prst="rect">
-            <a:avLst/>
-          </a:prstGeom>
-          <a:solidFill>
-            <a:srgbClr val="2E4D8A"/>
-          </a:solidFill>
-          <a:ln w="6350">
-            <a:solidFill>
-              <a:srgbClr val="6080C0"/>
-            </a:solidFill>
-          </a:ln>
-        </p:spPr>
-        <p:style>
-          <a:lnRef idx="1">
-            <a:schemeClr val="accent1"/>
-          </a:lnRef>
-          <a:fillRef idx="3">
-            <a:schemeClr val="accent1"/>
-          </a:fillRef>
-          <a:effectRef idx="2">
-            <a:schemeClr val="accent1"/>
-          </a:effectRef>
-          <a:fontRef idx="minor">
-            <a:schemeClr val="lt1"/>
-          </a:fontRef>
-        </p:style>
-        <p:txBody>
-          <a:bodyPr rtlCol="0" anchor="ctr"/>
-          <a:lstStyle/>
-          <a:p>
-            <a:pPr algn="ctr"/>
-          </a:p>
-        </p:txBody>
-      </p:sp>
-      <p:sp>
-        <p:nvSpPr>
-          <p:cNvPr id="40" name="TextBox 39"/>
-          <p:cNvSpPr txBox="1"/>
-          <p:nvPr/>
-        </p:nvSpPr>
-        <p:spPr>
-          <a:xfrm>
-            <a:off x="2761488" y="2404872"/>
-            <a:ext cx="1828800" cy="164592"/>
-          </a:xfrm>
-          <a:prstGeom prst="rect">
-            <a:avLst/>
-          </a:prstGeom>
-          <a:noFill/>
-        </p:spPr>
-        <p:txBody>
-          <a:bodyPr wrap="square">
-            <a:spAutoFit/>
-          </a:bodyPr>
-          <a:lstStyle/>
-          <a:p>
-            <a:pPr algn="l"/>
-            <a:r>
-              <a:rPr sz="750" b="1" i="0">
-                <a:solidFill>
-                  <a:srgbClr val="C9A84C"/>
-                </a:solidFill>
-              </a:rPr>
-              <a:t>SYLLABUS</a:t>
-            </a:r>
-          </a:p>
-        </p:txBody>
-      </p:sp>
-      <p:sp>
-        <p:nvSpPr>
-          <p:cNvPr id="41" name="TextBox 40"/>
-          <p:cNvSpPr txBox="1"/>
-          <p:nvPr/>
-        </p:nvSpPr>
-        <p:spPr>
-          <a:xfrm>
-            <a:off x="2761488" y="2596896"/>
-            <a:ext cx="1828800" cy="786384"/>
-          </a:xfrm>
-          <a:prstGeom prst="rect">
-            <a:avLst/>
-          </a:prstGeom>
-          <a:noFill/>
-        </p:spPr>
-        <p:txBody>
-          <a:bodyPr wrap="square">
-            <a:spAutoFit/>
-          </a:bodyPr>
-          <a:lstStyle/>
-          <a:p>
-            <a:pPr algn="l"/>
-            <a:r>
-              <a:rPr sz="950" b="0" i="0">
-                <a:solidFill>
-                  <a:srgbClr val="FFFFFF"/>
-                </a:solidFill>
-              </a:rPr>
-              <a:t>TM-20</a:t>
-            </a:r>
-          </a:p>
-        </p:txBody>
-      </p:sp>
-      <p:sp>
-        <p:nvSpPr>
-          <p:cNvPr id="42" name="Rectangle 41"/>
-          <p:cNvSpPr/>
-          <p:nvPr/>
-        </p:nvSpPr>
-        <p:spPr>
-          <a:xfrm>
-            <a:off x="4709160" y="2852928"/>
-            <a:ext cx="100584" cy="73152"/>
-          </a:xfrm>
-          <a:prstGeom prst="rect">
-            <a:avLst/>
-          </a:prstGeom>
-          <a:solidFill>
-            <a:srgbClr val="C9A84C"/>
-          </a:solidFill>
-          <a:ln>
-            <a:noFill/>
-          </a:ln>
-        </p:spPr>
-        <p:style>
-          <a:lnRef idx="1">
-            <a:schemeClr val="accent1"/>
-          </a:lnRef>
-          <a:fillRef idx="3">
-            <a:schemeClr val="accent1"/>
-          </a:fillRef>
-          <a:effectRef idx="2">
-            <a:schemeClr val="accent1"/>
-          </a:effectRef>
-          <a:fontRef idx="minor">
-            <a:schemeClr val="lt1"/>
-          </a:fontRef>
-        </p:style>
-        <p:txBody>
-          <a:bodyPr rtlCol="0" anchor="ctr"/>
-          <a:lstStyle/>
-          <a:p>
-            <a:pPr algn="ctr"/>
-          </a:p>
-        </p:txBody>
-      </p:sp>
-      <p:sp>
-        <p:nvSpPr>
-          <p:cNvPr id="43" name="Can 42"/>
-          <p:cNvSpPr/>
-          <p:nvPr/>
-        </p:nvSpPr>
-        <p:spPr>
-          <a:xfrm>
-            <a:off x="4718304" y="2770632"/>
-            <a:ext cx="118872" cy="237744"/>
-          </a:xfrm>
-          <a:prstGeom prst="can">
-            <a:avLst/>
-          </a:prstGeom>
-          <a:solidFill>
-            <a:srgbClr val="C9A84C"/>
-          </a:solidFill>
-          <a:ln>
-            <a:noFill/>
-          </a:ln>
-        </p:spPr>
-        <p:style>
-          <a:lnRef idx="1">
-            <a:schemeClr val="accent1"/>
-          </a:lnRef>
-          <a:fillRef idx="3">
-            <a:schemeClr val="accent1"/>
-          </a:fillRef>
-          <a:effectRef idx="2">
-            <a:schemeClr val="accent1"/>
-          </a:effectRef>
-          <a:fontRef idx="minor">
-            <a:schemeClr val="lt1"/>
-          </a:fontRef>
-        </p:style>
-        <p:txBody>
-          <a:bodyPr rtlCol="0" anchor="ctr"/>
-          <a:lstStyle/>
-          <a:p>
-            <a:pPr algn="ctr"/>
-          </a:p>
-        </p:txBody>
-      </p:sp>
-      <p:sp>
-        <p:nvSpPr>
-          <p:cNvPr id="44" name="Rectangle 43"/>
-          <p:cNvSpPr/>
-          <p:nvPr/>
-        </p:nvSpPr>
-        <p:spPr>
-          <a:xfrm>
-            <a:off x="4837176" y="2340864"/>
-            <a:ext cx="2011680" cy="1097280"/>
-          </a:xfrm>
-          <a:prstGeom prst="rect">
-            <a:avLst/>
-          </a:prstGeom>
-          <a:solidFill>
-            <a:srgbClr val="2E4D8A"/>
-          </a:solidFill>
-          <a:ln w="6350">
-            <a:solidFill>
-              <a:srgbClr val="6080C0"/>
-            </a:solidFill>
-          </a:ln>
-        </p:spPr>
-        <p:style>
-          <a:lnRef idx="1">
-            <a:schemeClr val="accent1"/>
-          </a:lnRef>
-          <a:fillRef idx="3">
-            <a:schemeClr val="accent1"/>
-          </a:fillRef>
-          <a:effectRef idx="2">
-            <a:schemeClr val="accent1"/>
-          </a:effectRef>
-          <a:fontRef idx="minor">
-            <a:schemeClr val="lt1"/>
-          </a:fontRef>
-        </p:style>
-        <p:txBody>
-          <a:bodyPr rtlCol="0" anchor="ctr"/>
-          <a:lstStyle/>
-          <a:p>
-            <a:pPr algn="ctr"/>
-          </a:p>
-        </p:txBody>
-      </p:sp>
-      <p:sp>
-        <p:nvSpPr>
-          <p:cNvPr id="45" name="TextBox 44"/>
-          <p:cNvSpPr txBox="1"/>
-          <p:nvPr/>
-        </p:nvSpPr>
-        <p:spPr>
-          <a:xfrm>
-            <a:off x="4928616" y="2404872"/>
-            <a:ext cx="1828800" cy="164592"/>
-          </a:xfrm>
-          <a:prstGeom prst="rect">
-            <a:avLst/>
-          </a:prstGeom>
-          <a:noFill/>
-        </p:spPr>
-        <p:txBody>
-          <a:bodyPr wrap="square">
-            <a:spAutoFit/>
-          </a:bodyPr>
-          <a:lstStyle/>
-          <a:p>
-            <a:pPr algn="l"/>
-            <a:r>
-              <a:rPr sz="750" b="1" i="0">
-                <a:solidFill>
-                  <a:srgbClr val="C9A84C"/>
-                </a:solidFill>
-              </a:rPr>
-              <a:t>EXERCISE</a:t>
-            </a:r>
-          </a:p>
-        </p:txBody>
-      </p:sp>
-      <p:sp>
-        <p:nvSpPr>
-          <p:cNvPr id="46" name="TextBox 45"/>
-          <p:cNvSpPr txBox="1"/>
-          <p:nvPr/>
-        </p:nvSpPr>
-        <p:spPr>
-          <a:xfrm>
-            <a:off x="4928616" y="2596896"/>
-            <a:ext cx="1828800" cy="786384"/>
-          </a:xfrm>
-          <a:prstGeom prst="rect">
-            <a:avLst/>
-          </a:prstGeom>
-          <a:noFill/>
-        </p:spPr>
-        <p:txBody>
-          <a:bodyPr wrap="square">
-            <a:spAutoFit/>
-          </a:bodyPr>
-          <a:lstStyle/>
-          <a:p>
-            <a:pPr algn="l"/>
-            <a:r>
-              <a:rPr sz="950" b="0" i="0">
-                <a:solidFill>
-                  <a:srgbClr val="FFFFFF"/>
-                </a:solidFill>
-              </a:rPr>
-              <a:t>EX-20  No-Code Builder</a:t>
-            </a:r>
-          </a:p>
-        </p:txBody>
-      </p:sp>
-      <p:sp>
-        <p:nvSpPr>
-          <p:cNvPr id="47" name="Rectangle 46"/>
-          <p:cNvSpPr/>
-          <p:nvPr/>
-        </p:nvSpPr>
-        <p:spPr>
-          <a:xfrm>
-            <a:off x="6876288" y="2852928"/>
-            <a:ext cx="100584" cy="73152"/>
-          </a:xfrm>
-          <a:prstGeom prst="rect">
-            <a:avLst/>
-          </a:prstGeom>
-          <a:solidFill>
-            <a:srgbClr val="C9A84C"/>
-          </a:solidFill>
-          <a:ln>
-            <a:noFill/>
-          </a:ln>
-        </p:spPr>
-        <p:style>
-          <a:lnRef idx="1">
-            <a:schemeClr val="accent1"/>
-          </a:lnRef>
-          <a:fillRef idx="3">
-            <a:schemeClr val="accent1"/>
-          </a:fillRef>
-          <a:effectRef idx="2">
-            <a:schemeClr val="accent1"/>
-          </a:effectRef>
-          <a:fontRef idx="minor">
-            <a:schemeClr val="lt1"/>
-          </a:fontRef>
-        </p:style>
-        <p:txBody>
-          <a:bodyPr rtlCol="0" anchor="ctr"/>
-          <a:lstStyle/>
-          <a:p>
-            <a:pPr algn="ctr"/>
-          </a:p>
-        </p:txBody>
-      </p:sp>
-      <p:sp>
-        <p:nvSpPr>
-          <p:cNvPr id="48" name="Can 47"/>
-          <p:cNvSpPr/>
-          <p:nvPr/>
-        </p:nvSpPr>
-        <p:spPr>
-          <a:xfrm>
-            <a:off x="6885432" y="2770632"/>
-            <a:ext cx="118872" cy="237744"/>
-          </a:xfrm>
-          <a:prstGeom prst="can">
-            <a:avLst/>
-          </a:prstGeom>
-          <a:solidFill>
-            <a:srgbClr val="C9A84C"/>
-          </a:solidFill>
-          <a:ln>
-            <a:noFill/>
-          </a:ln>
-        </p:spPr>
-        <p:style>
-          <a:lnRef idx="1">
-            <a:schemeClr val="accent1"/>
-          </a:lnRef>
-          <a:fillRef idx="3">
-            <a:schemeClr val="accent1"/>
-          </a:fillRef>
-          <a:effectRef idx="2">
-            <a:schemeClr val="accent1"/>
-          </a:effectRef>
-          <a:fontRef idx="minor">
-            <a:schemeClr val="lt1"/>
-          </a:fontRef>
-        </p:style>
-        <p:txBody>
-          <a:bodyPr rtlCol="0" anchor="ctr"/>
-          <a:lstStyle/>
-          <a:p>
-            <a:pPr algn="ctr"/>
-          </a:p>
-        </p:txBody>
-      </p:sp>
-      <p:sp>
-        <p:nvSpPr>
-          <p:cNvPr id="49" name="Rectangle 48"/>
-          <p:cNvSpPr/>
-          <p:nvPr/>
-        </p:nvSpPr>
-        <p:spPr>
-          <a:xfrm>
-            <a:off x="7004304" y="2340864"/>
-            <a:ext cx="2011680" cy="1097280"/>
-          </a:xfrm>
-          <a:prstGeom prst="rect">
-            <a:avLst/>
-          </a:prstGeom>
-          <a:solidFill>
-            <a:srgbClr val="2E4D8A"/>
-          </a:solidFill>
-          <a:ln w="6350">
-            <a:solidFill>
-              <a:srgbClr val="6080C0"/>
-            </a:solidFill>
-          </a:ln>
-        </p:spPr>
-        <p:style>
-          <a:lnRef idx="1">
-            <a:schemeClr val="accent1"/>
-          </a:lnRef>
-          <a:fillRef idx="3">
-            <a:schemeClr val="accent1"/>
-          </a:fillRef>
-          <a:effectRef idx="2">
-            <a:schemeClr val="accent1"/>
-          </a:effectRef>
-          <a:fontRef idx="minor">
-            <a:schemeClr val="lt1"/>
-          </a:fontRef>
-        </p:style>
-        <p:txBody>
-          <a:bodyPr rtlCol="0" anchor="ctr"/>
-          <a:lstStyle/>
-          <a:p>
-            <a:pPr algn="ctr"/>
-          </a:p>
-        </p:txBody>
-      </p:sp>
-      <p:sp>
-        <p:nvSpPr>
-          <p:cNvPr id="50" name="TextBox 49"/>
-          <p:cNvSpPr txBox="1"/>
-          <p:nvPr/>
-        </p:nvSpPr>
-        <p:spPr>
-          <a:xfrm>
-            <a:off x="7095744" y="2404872"/>
-            <a:ext cx="1828800" cy="164592"/>
-          </a:xfrm>
-          <a:prstGeom prst="rect">
-            <a:avLst/>
-          </a:prstGeom>
-          <a:noFill/>
-        </p:spPr>
-        <p:txBody>
-          <a:bodyPr wrap="square">
-            <a:spAutoFit/>
-          </a:bodyPr>
-          <a:lstStyle/>
-          <a:p>
-            <a:pPr algn="l"/>
-            <a:r>
-              <a:rPr sz="750" b="1" i="0">
-                <a:solidFill>
-                  <a:srgbClr val="C9A84C"/>
-                </a:solidFill>
-              </a:rPr>
-              <a:t>EXAMS</a:t>
-            </a:r>
-          </a:p>
-        </p:txBody>
-      </p:sp>
-      <p:sp>
-        <p:nvSpPr>
-          <p:cNvPr id="51" name="TextBox 50"/>
-          <p:cNvSpPr txBox="1"/>
-          <p:nvPr/>
-        </p:nvSpPr>
-        <p:spPr>
-          <a:xfrm>
-            <a:off x="7095744" y="2596896"/>
-            <a:ext cx="1828800" cy="786384"/>
-          </a:xfrm>
-          <a:prstGeom prst="rect">
-            <a:avLst/>
-          </a:prstGeom>
-          <a:noFill/>
-        </p:spPr>
-        <p:txBody>
-          <a:bodyPr wrap="square">
-            <a:spAutoFit/>
-          </a:bodyPr>
-          <a:lstStyle/>
-          <a:p>
-            <a:pPr algn="l"/>
-            <a:r>
-              <a:rPr sz="950" b="0" i="0">
-                <a:solidFill>
-                  <a:srgbClr val="FFFFFF"/>
-                </a:solidFill>
-              </a:rPr>
-              <a:t>Pre-assessment
-Post-assessment</a:t>
-            </a:r>
-          </a:p>
-        </p:txBody>
-      </p:sp>
-      <p:cxnSp>
-        <p:nvCxnSpPr>
-          <p:cNvPr id="52" name="Connector 51"/>
-          <p:cNvCxnSpPr/>
-          <p:nvPr/>
-        </p:nvCxnSpPr>
-        <p:spPr>
-          <a:xfrm>
-            <a:off x="2514600" y="2889504.0"/>
-            <a:ext cx="6775704" cy="0.0"/>
-          </a:xfrm>
-          <a:prstGeom prst="line">
-            <a:avLst/>
-          </a:prstGeom>
-          <a:ln w="19050">
-            <a:solidFill>
-              <a:srgbClr val="C9A84C"/>
-            </a:solidFill>
-            <a:prstDash val="dash"/>
-          </a:ln>
-        </p:spPr>
-        <p:style>
-          <a:lnRef idx="2">
-            <a:schemeClr val="accent1"/>
-          </a:lnRef>
-          <a:fillRef idx="0">
-            <a:schemeClr val="accent1"/>
-          </a:fillRef>
-          <a:effectRef idx="1">
-            <a:schemeClr val="accent1"/>
-          </a:effectRef>
-          <a:fontRef idx="minor">
-            <a:schemeClr val="tx1"/>
-          </a:fontRef>
-        </p:style>
-      </p:cxnSp>
-      <p:sp>
-        <p:nvSpPr>
-          <p:cNvPr id="53" name="Rectangle 52"/>
-          <p:cNvSpPr/>
-          <p:nvPr/>
-        </p:nvSpPr>
-        <p:spPr>
-          <a:xfrm>
-            <a:off x="1371600" y="3438144"/>
-            <a:ext cx="91440" cy="219456"/>
-          </a:xfrm>
-          <a:prstGeom prst="rect">
-            <a:avLst/>
-          </a:prstGeom>
-          <a:solidFill>
-            <a:srgbClr val="C9A84C"/>
-          </a:solidFill>
-          <a:ln>
-            <a:noFill/>
-          </a:ln>
-        </p:spPr>
-        <p:style>
-          <a:lnRef idx="1">
-            <a:schemeClr val="accent1"/>
-          </a:lnRef>
-          <a:fillRef idx="3">
-            <a:schemeClr val="accent1"/>
-          </a:fillRef>
-          <a:effectRef idx="2">
-            <a:schemeClr val="accent1"/>
-          </a:effectRef>
-          <a:fontRef idx="minor">
-            <a:schemeClr val="lt1"/>
-          </a:fontRef>
-        </p:style>
-        <p:txBody>
-          <a:bodyPr rtlCol="0" anchor="ctr"/>
-          <a:lstStyle/>
-          <a:p>
-            <a:pPr algn="ctr"/>
-          </a:p>
-        </p:txBody>
-      </p:sp>
-      <p:sp>
-        <p:nvSpPr>
-          <p:cNvPr id="54" name="Can 53"/>
-          <p:cNvSpPr/>
-          <p:nvPr/>
-        </p:nvSpPr>
-        <p:spPr>
-          <a:xfrm>
-            <a:off x="1298448" y="3529584"/>
-            <a:ext cx="237744" cy="256032"/>
-          </a:xfrm>
-          <a:prstGeom prst="can">
-            <a:avLst/>
-          </a:prstGeom>
-          <a:solidFill>
-            <a:srgbClr val="C9A84C"/>
-          </a:solidFill>
-          <a:ln>
-            <a:noFill/>
-          </a:ln>
-        </p:spPr>
-        <p:style>
-          <a:lnRef idx="1">
-            <a:schemeClr val="accent1"/>
-          </a:lnRef>
-          <a:fillRef idx="3">
-            <a:schemeClr val="accent1"/>
-          </a:fillRef>
-          <a:effectRef idx="2">
-            <a:schemeClr val="accent1"/>
-          </a:effectRef>
-          <a:fontRef idx="minor">
-            <a:schemeClr val="lt1"/>
-          </a:fontRef>
-        </p:style>
-        <p:txBody>
-          <a:bodyPr rtlCol="0" anchor="ctr"/>
-          <a:lstStyle/>
-          <a:p>
-            <a:pPr algn="ctr"/>
-          </a:p>
-        </p:txBody>
-      </p:sp>
-      <p:sp>
-        <p:nvSpPr>
-          <p:cNvPr id="55" name="Rectangle 54"/>
-          <p:cNvSpPr/>
-          <p:nvPr/>
-        </p:nvSpPr>
-        <p:spPr>
-          <a:xfrm>
-            <a:off x="320040" y="3785616"/>
-            <a:ext cx="2194560" cy="1097280"/>
-          </a:xfrm>
-          <a:prstGeom prst="rect">
-            <a:avLst/>
-          </a:prstGeom>
-          <a:solidFill>
-            <a:srgbClr val="3A62AA"/>
-          </a:solidFill>
-          <a:ln w="9525">
-            <a:solidFill>
-              <a:srgbClr val="FFFFFF"/>
-            </a:solidFill>
-          </a:ln>
-        </p:spPr>
-        <p:style>
-          <a:lnRef idx="1">
-            <a:schemeClr val="accent1"/>
-          </a:lnRef>
-          <a:fillRef idx="3">
-            <a:schemeClr val="accent1"/>
-          </a:fillRef>
-          <a:effectRef idx="2">
-            <a:schemeClr val="accent1"/>
-          </a:effectRef>
-          <a:fontRef idx="minor">
-            <a:schemeClr val="lt1"/>
-          </a:fontRef>
-        </p:style>
-        <p:txBody>
-          <a:bodyPr rtlCol="0" anchor="ctr"/>
-          <a:lstStyle/>
-          <a:p>
-            <a:pPr algn="ctr"/>
-          </a:p>
-        </p:txBody>
-      </p:sp>
-      <p:sp>
-        <p:nvSpPr>
-          <p:cNvPr id="56" name="TextBox 55"/>
-          <p:cNvSpPr txBox="1"/>
-          <p:nvPr/>
-        </p:nvSpPr>
-        <p:spPr>
-          <a:xfrm>
-            <a:off x="438912" y="3849624"/>
-            <a:ext cx="1956816" cy="310896"/>
-          </a:xfrm>
-          <a:prstGeom prst="rect">
-            <a:avLst/>
-          </a:prstGeom>
-          <a:noFill/>
-        </p:spPr>
-        <p:txBody>
-          <a:bodyPr wrap="square">
-            <a:spAutoFit/>
-          </a:bodyPr>
-          <a:lstStyle/>
-          <a:p>
-            <a:pPr algn="l"/>
-            <a:r>
-              <a:rPr sz="2200" b="1" i="0">
-                <a:solidFill>
-                  <a:srgbClr val="FFFFFF"/>
-                </a:solidFill>
-              </a:rPr>
-              <a:t>TM-30</a:t>
-            </a:r>
-          </a:p>
-        </p:txBody>
-      </p:sp>
-      <p:sp>
-        <p:nvSpPr>
-          <p:cNvPr id="57" name="TextBox 56"/>
-          <p:cNvSpPr txBox="1"/>
-          <p:nvPr/>
-        </p:nvSpPr>
-        <p:spPr>
-          <a:xfrm>
-            <a:off x="438912" y="4151376"/>
-            <a:ext cx="1956816" cy="201168"/>
-          </a:xfrm>
-          <a:prstGeom prst="rect">
-            <a:avLst/>
-          </a:prstGeom>
-          <a:noFill/>
-        </p:spPr>
-        <p:txBody>
-          <a:bodyPr wrap="square">
-            <a:spAutoFit/>
-          </a:bodyPr>
-          <a:lstStyle/>
-          <a:p>
-            <a:pPr algn="l"/>
-            <a:r>
-              <a:rPr sz="1000" b="1" i="0">
-                <a:solidFill>
-                  <a:srgbClr val="C9A84C"/>
-                </a:solidFill>
-              </a:rPr>
-              <a:t>ADVANCED BUILDER</a:t>
-            </a:r>
-          </a:p>
-        </p:txBody>
-      </p:sp>
-      <p:sp>
-        <p:nvSpPr>
-          <p:cNvPr id="58" name="TextBox 57"/>
-          <p:cNvSpPr txBox="1"/>
-          <p:nvPr/>
-        </p:nvSpPr>
-        <p:spPr>
-          <a:xfrm>
-            <a:off x="438912" y="4352544"/>
-            <a:ext cx="1956816" cy="182880"/>
-          </a:xfrm>
-          <a:prstGeom prst="rect">
-            <a:avLst/>
-          </a:prstGeom>
-          <a:noFill/>
-        </p:spPr>
-        <p:txBody>
-          <a:bodyPr wrap="square">
-            <a:spAutoFit/>
-          </a:bodyPr>
-          <a:lstStyle/>
-          <a:p>
-            <a:pPr algn="l"/>
-            <a:r>
-              <a:rPr sz="950" b="0" i="0">
-                <a:solidFill>
-                  <a:srgbClr val="FFFFFF"/>
-                </a:solidFill>
-              </a:rPr>
-              <a:t>40 hrs  ·  Unit Data Leads</a:t>
-            </a:r>
-          </a:p>
-        </p:txBody>
-      </p:sp>
-      <p:sp>
-        <p:nvSpPr>
-          <p:cNvPr id="59" name="TextBox 58"/>
-          <p:cNvSpPr txBox="1"/>
-          <p:nvPr/>
-        </p:nvSpPr>
-        <p:spPr>
-          <a:xfrm>
-            <a:off x="438912" y="4553712"/>
-            <a:ext cx="1956816" cy="182880"/>
-          </a:xfrm>
-          <a:prstGeom prst="rect">
-            <a:avLst/>
-          </a:prstGeom>
-          <a:noFill/>
-        </p:spPr>
-        <p:txBody>
-          <a:bodyPr wrap="square">
-            <a:spAutoFit/>
-          </a:bodyPr>
-          <a:lstStyle/>
-          <a:p>
-            <a:pPr algn="l"/>
-            <a:r>
-              <a:rPr sz="850" b="0" i="1">
-                <a:solidFill>
-                  <a:srgbClr val="CCDDFF"/>
-                </a:solidFill>
-              </a:rPr>
-              <a:t>Prereq: TM-20</a:t>
-            </a:r>
-          </a:p>
-        </p:txBody>
-      </p:sp>
-      <p:sp>
-        <p:nvSpPr>
-          <p:cNvPr id="60" name="Rectangle 59"/>
-          <p:cNvSpPr/>
-          <p:nvPr/>
-        </p:nvSpPr>
-        <p:spPr>
-          <a:xfrm>
-            <a:off x="2542032" y="4297680"/>
-            <a:ext cx="100584" cy="73152"/>
-          </a:xfrm>
-          <a:prstGeom prst="rect">
-            <a:avLst/>
-          </a:prstGeom>
-          <a:solidFill>
-            <a:srgbClr val="C9A84C"/>
-          </a:solidFill>
-          <a:ln>
-            <a:noFill/>
-          </a:ln>
-        </p:spPr>
-        <p:style>
-          <a:lnRef idx="1">
-            <a:schemeClr val="accent1"/>
-          </a:lnRef>
-          <a:fillRef idx="3">
-            <a:schemeClr val="accent1"/>
-          </a:fillRef>
-          <a:effectRef idx="2">
-            <a:schemeClr val="accent1"/>
-          </a:effectRef>
-          <a:fontRef idx="minor">
-            <a:schemeClr val="lt1"/>
-          </a:fontRef>
-        </p:style>
-        <p:txBody>
-          <a:bodyPr rtlCol="0" anchor="ctr"/>
-          <a:lstStyle/>
-          <a:p>
-            <a:pPr algn="ctr"/>
-          </a:p>
-        </p:txBody>
-      </p:sp>
-      <p:sp>
-        <p:nvSpPr>
-          <p:cNvPr id="61" name="Can 60"/>
-          <p:cNvSpPr/>
-          <p:nvPr/>
-        </p:nvSpPr>
-        <p:spPr>
-          <a:xfrm>
-            <a:off x="2551176" y="4215384"/>
-            <a:ext cx="118872" cy="237744"/>
-          </a:xfrm>
-          <a:prstGeom prst="can">
-            <a:avLst/>
-          </a:prstGeom>
-          <a:solidFill>
-            <a:srgbClr val="C9A84C"/>
-          </a:solidFill>
-          <a:ln>
-            <a:noFill/>
-          </a:ln>
-        </p:spPr>
-        <p:style>
-          <a:lnRef idx="1">
-            <a:schemeClr val="accent1"/>
-          </a:lnRef>
-          <a:fillRef idx="3">
-            <a:schemeClr val="accent1"/>
-          </a:fillRef>
-          <a:effectRef idx="2">
-            <a:schemeClr val="accent1"/>
-          </a:effectRef>
-          <a:fontRef idx="minor">
-            <a:schemeClr val="lt1"/>
-          </a:fontRef>
-        </p:style>
-        <p:txBody>
-          <a:bodyPr rtlCol="0" anchor="ctr"/>
-          <a:lstStyle/>
-          <a:p>
-            <a:pPr algn="ctr"/>
-          </a:p>
-        </p:txBody>
-      </p:sp>
-      <p:sp>
-        <p:nvSpPr>
-          <p:cNvPr id="62" name="Rectangle 61"/>
-          <p:cNvSpPr/>
-          <p:nvPr/>
-        </p:nvSpPr>
-        <p:spPr>
-          <a:xfrm>
-            <a:off x="2670048" y="3785616"/>
-            <a:ext cx="2011680" cy="1097280"/>
-          </a:xfrm>
-          <a:prstGeom prst="rect">
-            <a:avLst/>
-          </a:prstGeom>
-          <a:solidFill>
-            <a:srgbClr val="2E4D8A"/>
-          </a:solidFill>
-          <a:ln w="6350">
-            <a:solidFill>
-              <a:srgbClr val="6080C0"/>
-            </a:solidFill>
-          </a:ln>
-        </p:spPr>
-        <p:style>
-          <a:lnRef idx="1">
-            <a:schemeClr val="accent1"/>
-          </a:lnRef>
-          <a:fillRef idx="3">
-            <a:schemeClr val="accent1"/>
-          </a:fillRef>
-          <a:effectRef idx="2">
-            <a:schemeClr val="accent1"/>
-          </a:effectRef>
-          <a:fontRef idx="minor">
-            <a:schemeClr val="lt1"/>
-          </a:fontRef>
-        </p:style>
-        <p:txBody>
-          <a:bodyPr rtlCol="0" anchor="ctr"/>
-          <a:lstStyle/>
-          <a:p>
-            <a:pPr algn="ctr"/>
-          </a:p>
-        </p:txBody>
-      </p:sp>
-      <p:sp>
-        <p:nvSpPr>
-          <p:cNvPr id="63" name="TextBox 62"/>
-          <p:cNvSpPr txBox="1"/>
-          <p:nvPr/>
-        </p:nvSpPr>
-        <p:spPr>
-          <a:xfrm>
-            <a:off x="2761488" y="3849624"/>
-            <a:ext cx="1828800" cy="164592"/>
-          </a:xfrm>
-          <a:prstGeom prst="rect">
-            <a:avLst/>
-          </a:prstGeom>
-          <a:noFill/>
-        </p:spPr>
-        <p:txBody>
-          <a:bodyPr wrap="square">
-            <a:spAutoFit/>
-          </a:bodyPr>
-          <a:lstStyle/>
-          <a:p>
-            <a:pPr algn="l"/>
-            <a:r>
-              <a:rPr sz="750" b="1" i="0">
-                <a:solidFill>
-                  <a:srgbClr val="C9A84C"/>
-                </a:solidFill>
-              </a:rPr>
-              <a:t>SYLLABUS</a:t>
-            </a:r>
-          </a:p>
-        </p:txBody>
-      </p:sp>
-      <p:sp>
-        <p:nvSpPr>
-          <p:cNvPr id="64" name="TextBox 63"/>
-          <p:cNvSpPr txBox="1"/>
-          <p:nvPr/>
-        </p:nvSpPr>
-        <p:spPr>
-          <a:xfrm>
-            <a:off x="2761488" y="4041648"/>
-            <a:ext cx="1828800" cy="786384"/>
-          </a:xfrm>
-          <a:prstGeom prst="rect">
-            <a:avLst/>
-          </a:prstGeom>
-          <a:noFill/>
-        </p:spPr>
-        <p:txBody>
-          <a:bodyPr wrap="square">
-            <a:spAutoFit/>
-          </a:bodyPr>
-          <a:lstStyle/>
-          <a:p>
-            <a:pPr algn="l"/>
-            <a:r>
-              <a:rPr sz="950" b="0" i="0">
-                <a:solidFill>
-                  <a:srgbClr val="FFFFFF"/>
-                </a:solidFill>
-              </a:rPr>
-              <a:t>TM-30</a:t>
-            </a:r>
-          </a:p>
-        </p:txBody>
-      </p:sp>
-      <p:sp>
-        <p:nvSpPr>
-          <p:cNvPr id="65" name="Rectangle 64"/>
-          <p:cNvSpPr/>
-          <p:nvPr/>
-        </p:nvSpPr>
-        <p:spPr>
-          <a:xfrm>
-            <a:off x="4709160" y="4297680"/>
-            <a:ext cx="100584" cy="73152"/>
-          </a:xfrm>
-          <a:prstGeom prst="rect">
-            <a:avLst/>
-          </a:prstGeom>
-          <a:solidFill>
-            <a:srgbClr val="C9A84C"/>
-          </a:solidFill>
-          <a:ln>
-            <a:noFill/>
-          </a:ln>
-        </p:spPr>
-        <p:style>
-          <a:lnRef idx="1">
-            <a:schemeClr val="accent1"/>
-          </a:lnRef>
-          <a:fillRef idx="3">
-            <a:schemeClr val="accent1"/>
-          </a:fillRef>
-          <a:effectRef idx="2">
-            <a:schemeClr val="accent1"/>
-          </a:effectRef>
-          <a:fontRef idx="minor">
-            <a:schemeClr val="lt1"/>
-          </a:fontRef>
-        </p:style>
-        <p:txBody>
-          <a:bodyPr rtlCol="0" anchor="ctr"/>
-          <a:lstStyle/>
-          <a:p>
-            <a:pPr algn="ctr"/>
-          </a:p>
-        </p:txBody>
-      </p:sp>
-      <p:sp>
-        <p:nvSpPr>
-          <p:cNvPr id="66" name="Can 65"/>
-          <p:cNvSpPr/>
-          <p:nvPr/>
-        </p:nvSpPr>
-        <p:spPr>
-          <a:xfrm>
-            <a:off x="4718304" y="4215384"/>
-            <a:ext cx="118872" cy="237744"/>
-          </a:xfrm>
-          <a:prstGeom prst="can">
-            <a:avLst/>
-          </a:prstGeom>
-          <a:solidFill>
-            <a:srgbClr val="C9A84C"/>
-          </a:solidFill>
-          <a:ln>
-            <a:noFill/>
-          </a:ln>
-        </p:spPr>
-        <p:style>
-          <a:lnRef idx="1">
-            <a:schemeClr val="accent1"/>
-          </a:lnRef>
-          <a:fillRef idx="3">
-            <a:schemeClr val="accent1"/>
-          </a:fillRef>
-          <a:effectRef idx="2">
-            <a:schemeClr val="accent1"/>
-          </a:effectRef>
-          <a:fontRef idx="minor">
-            <a:schemeClr val="lt1"/>
-          </a:fontRef>
-        </p:style>
-        <p:txBody>
-          <a:bodyPr rtlCol="0" anchor="ctr"/>
-          <a:lstStyle/>
-          <a:p>
-            <a:pPr algn="ctr"/>
-          </a:p>
-        </p:txBody>
-      </p:sp>
-      <p:sp>
-        <p:nvSpPr>
-          <p:cNvPr id="67" name="Rectangle 66"/>
-          <p:cNvSpPr/>
-          <p:nvPr/>
-        </p:nvSpPr>
-        <p:spPr>
-          <a:xfrm>
-            <a:off x="4837176" y="3785616"/>
-            <a:ext cx="2011680" cy="1097280"/>
-          </a:xfrm>
-          <a:prstGeom prst="rect">
-            <a:avLst/>
-          </a:prstGeom>
-          <a:solidFill>
-            <a:srgbClr val="2E4D8A"/>
-          </a:solidFill>
-          <a:ln w="6350">
-            <a:solidFill>
-              <a:srgbClr val="6080C0"/>
-            </a:solidFill>
-          </a:ln>
-        </p:spPr>
-        <p:style>
-          <a:lnRef idx="1">
-            <a:schemeClr val="accent1"/>
-          </a:lnRef>
-          <a:fillRef idx="3">
-            <a:schemeClr val="accent1"/>
-          </a:fillRef>
-          <a:effectRef idx="2">
-            <a:schemeClr val="accent1"/>
-          </a:effectRef>
-          <a:fontRef idx="minor">
-            <a:schemeClr val="lt1"/>
-          </a:fontRef>
-        </p:style>
-        <p:txBody>
-          <a:bodyPr rtlCol="0" anchor="ctr"/>
-          <a:lstStyle/>
-          <a:p>
-            <a:pPr algn="ctr"/>
-          </a:p>
-        </p:txBody>
-      </p:sp>
-      <p:sp>
-        <p:nvSpPr>
-          <p:cNvPr id="68" name="TextBox 67"/>
-          <p:cNvSpPr txBox="1"/>
-          <p:nvPr/>
-        </p:nvSpPr>
-        <p:spPr>
-          <a:xfrm>
-            <a:off x="4928616" y="3849624"/>
-            <a:ext cx="1828800" cy="164592"/>
-          </a:xfrm>
-          <a:prstGeom prst="rect">
-            <a:avLst/>
-          </a:prstGeom>
-          <a:noFill/>
-        </p:spPr>
-        <p:txBody>
-          <a:bodyPr wrap="square">
-            <a:spAutoFit/>
-          </a:bodyPr>
-          <a:lstStyle/>
-          <a:p>
-            <a:pPr algn="l"/>
-            <a:r>
-              <a:rPr sz="750" b="1" i="0">
-                <a:solidFill>
-                  <a:srgbClr val="C9A84C"/>
-                </a:solidFill>
-              </a:rPr>
-              <a:t>EXERCISE</a:t>
-            </a:r>
-          </a:p>
-        </p:txBody>
-      </p:sp>
-      <p:sp>
-        <p:nvSpPr>
-          <p:cNvPr id="69" name="TextBox 68"/>
-          <p:cNvSpPr txBox="1"/>
-          <p:nvPr/>
-        </p:nvSpPr>
-        <p:spPr>
-          <a:xfrm>
-            <a:off x="4928616" y="4041648"/>
-            <a:ext cx="1828800" cy="786384"/>
-          </a:xfrm>
-          <a:prstGeom prst="rect">
-            <a:avLst/>
-          </a:prstGeom>
-          <a:noFill/>
-        </p:spPr>
-        <p:txBody>
-          <a:bodyPr wrap="square">
-            <a:spAutoFit/>
-          </a:bodyPr>
-          <a:lstStyle/>
-          <a:p>
-            <a:pPr algn="l"/>
-            <a:r>
-              <a:rPr sz="950" b="0" i="0">
-                <a:solidFill>
-                  <a:srgbClr val="FFFFFF"/>
-                </a:solidFill>
-              </a:rPr>
-              <a:t>EX-30  Adv Builder</a:t>
-            </a:r>
-          </a:p>
-        </p:txBody>
-      </p:sp>
-      <p:sp>
-        <p:nvSpPr>
-          <p:cNvPr id="70" name="Rectangle 69"/>
-          <p:cNvSpPr/>
-          <p:nvPr/>
-        </p:nvSpPr>
-        <p:spPr>
-          <a:xfrm>
-            <a:off x="6876288" y="4297680"/>
-            <a:ext cx="100584" cy="73152"/>
-          </a:xfrm>
-          <a:prstGeom prst="rect">
-            <a:avLst/>
-          </a:prstGeom>
-          <a:solidFill>
-            <a:srgbClr val="C9A84C"/>
-          </a:solidFill>
-          <a:ln>
-            <a:noFill/>
-          </a:ln>
-        </p:spPr>
-        <p:style>
-          <a:lnRef idx="1">
-            <a:schemeClr val="accent1"/>
-          </a:lnRef>
-          <a:fillRef idx="3">
-            <a:schemeClr val="accent1"/>
-          </a:fillRef>
-          <a:effectRef idx="2">
-            <a:schemeClr val="accent1"/>
-          </a:effectRef>
-          <a:fontRef idx="minor">
-            <a:schemeClr val="lt1"/>
-          </a:fontRef>
-        </p:style>
-        <p:txBody>
-          <a:bodyPr rtlCol="0" anchor="ctr"/>
-          <a:lstStyle/>
-          <a:p>
-            <a:pPr algn="ctr"/>
-          </a:p>
-        </p:txBody>
-      </p:sp>
-      <p:sp>
-        <p:nvSpPr>
-          <p:cNvPr id="71" name="Can 70"/>
-          <p:cNvSpPr/>
-          <p:nvPr/>
-        </p:nvSpPr>
-        <p:spPr>
-          <a:xfrm>
-            <a:off x="6885432" y="4215384"/>
-            <a:ext cx="118872" cy="237744"/>
-          </a:xfrm>
-          <a:prstGeom prst="can">
-            <a:avLst/>
-          </a:prstGeom>
-          <a:solidFill>
-            <a:srgbClr val="C9A84C"/>
-          </a:solidFill>
-          <a:ln>
-            <a:noFill/>
-          </a:ln>
-        </p:spPr>
-        <p:style>
-          <a:lnRef idx="1">
-            <a:schemeClr val="accent1"/>
-          </a:lnRef>
-          <a:fillRef idx="3">
-            <a:schemeClr val="accent1"/>
-          </a:fillRef>
-          <a:effectRef idx="2">
-            <a:schemeClr val="accent1"/>
-          </a:effectRef>
-          <a:fontRef idx="minor">
-            <a:schemeClr val="lt1"/>
-          </a:fontRef>
-        </p:style>
-        <p:txBody>
-          <a:bodyPr rtlCol="0" anchor="ctr"/>
-          <a:lstStyle/>
-          <a:p>
-            <a:pPr algn="ctr"/>
-          </a:p>
-        </p:txBody>
-      </p:sp>
-      <p:sp>
-        <p:nvSpPr>
-          <p:cNvPr id="72" name="Rectangle 71"/>
-          <p:cNvSpPr/>
-          <p:nvPr/>
-        </p:nvSpPr>
-        <p:spPr>
-          <a:xfrm>
-            <a:off x="7004304" y="3785616"/>
-            <a:ext cx="2011680" cy="1097280"/>
-          </a:xfrm>
-          <a:prstGeom prst="rect">
-            <a:avLst/>
-          </a:prstGeom>
-          <a:solidFill>
-            <a:srgbClr val="2E4D8A"/>
-          </a:solidFill>
-          <a:ln w="6350">
-            <a:solidFill>
-              <a:srgbClr val="6080C0"/>
-            </a:solidFill>
-          </a:ln>
-        </p:spPr>
-        <p:style>
-          <a:lnRef idx="1">
-            <a:schemeClr val="accent1"/>
-          </a:lnRef>
-          <a:fillRef idx="3">
-            <a:schemeClr val="accent1"/>
-          </a:fillRef>
-          <a:effectRef idx="2">
-            <a:schemeClr val="accent1"/>
-          </a:effectRef>
-          <a:fontRef idx="minor">
-            <a:schemeClr val="lt1"/>
-          </a:fontRef>
-        </p:style>
-        <p:txBody>
-          <a:bodyPr rtlCol="0" anchor="ctr"/>
-          <a:lstStyle/>
-          <a:p>
-            <a:pPr algn="ctr"/>
-          </a:p>
-        </p:txBody>
-      </p:sp>
-      <p:sp>
-        <p:nvSpPr>
-          <p:cNvPr id="73" name="TextBox 72"/>
-          <p:cNvSpPr txBox="1"/>
-          <p:nvPr/>
-        </p:nvSpPr>
-        <p:spPr>
-          <a:xfrm>
-            <a:off x="7095744" y="3849624"/>
-            <a:ext cx="1828800" cy="164592"/>
-          </a:xfrm>
-          <a:prstGeom prst="rect">
-            <a:avLst/>
-          </a:prstGeom>
-          <a:noFill/>
-        </p:spPr>
-        <p:txBody>
-          <a:bodyPr wrap="square">
-            <a:spAutoFit/>
-          </a:bodyPr>
-          <a:lstStyle/>
-          <a:p>
-            <a:pPr algn="l"/>
-            <a:r>
-              <a:rPr sz="750" b="1" i="0">
-                <a:solidFill>
-                  <a:srgbClr val="C9A84C"/>
-                </a:solidFill>
-              </a:rPr>
-              <a:t>EXAMS</a:t>
-            </a:r>
-          </a:p>
-        </p:txBody>
-      </p:sp>
-      <p:sp>
-        <p:nvSpPr>
-          <p:cNvPr id="74" name="TextBox 73"/>
-          <p:cNvSpPr txBox="1"/>
-          <p:nvPr/>
-        </p:nvSpPr>
-        <p:spPr>
-          <a:xfrm>
-            <a:off x="7095744" y="4041648"/>
-            <a:ext cx="1828800" cy="786384"/>
-          </a:xfrm>
-          <a:prstGeom prst="rect">
-            <a:avLst/>
-          </a:prstGeom>
-          <a:noFill/>
-        </p:spPr>
-        <p:txBody>
-          <a:bodyPr wrap="square">
-            <a:spAutoFit/>
-          </a:bodyPr>
-          <a:lstStyle/>
-          <a:p>
-            <a:pPr algn="l"/>
-            <a:r>
-              <a:rPr sz="950" b="0" i="0">
-                <a:solidFill>
-                  <a:srgbClr val="FFFFFF"/>
-                </a:solidFill>
-              </a:rPr>
-              <a:t>Pre-assessment
-Post-assessment</a:t>
-            </a:r>
-          </a:p>
-        </p:txBody>
-      </p:sp>
-      <p:sp>
-        <p:nvSpPr>
-          <p:cNvPr id="75" name="Rectangle 74"/>
-          <p:cNvSpPr/>
-          <p:nvPr/>
-        </p:nvSpPr>
-        <p:spPr>
-          <a:xfrm>
-            <a:off x="9290304" y="2340864"/>
-            <a:ext cx="2578608" cy="2542032"/>
-          </a:xfrm>
-          <a:prstGeom prst="rect">
-            <a:avLst/>
-          </a:prstGeom>
-          <a:solidFill>
-            <a:srgbClr val="3A2204"/>
-          </a:solidFill>
-          <a:ln w="19050">
-            <a:solidFill>
-              <a:srgbClr val="C9A84C"/>
-            </a:solidFill>
-            <a:prstDash val="dashDot"/>
-          </a:ln>
-        </p:spPr>
-        <p:style>
-          <a:lnRef idx="1">
-            <a:schemeClr val="accent1"/>
-          </a:lnRef>
-          <a:fillRef idx="3">
-            <a:schemeClr val="accent1"/>
-          </a:fillRef>
-          <a:effectRef idx="2">
-            <a:schemeClr val="accent1"/>
-          </a:effectRef>
-          <a:fontRef idx="minor">
-            <a:schemeClr val="lt1"/>
-          </a:fontRef>
-        </p:style>
-        <p:txBody>
-          <a:bodyPr rtlCol="0" anchor="ctr"/>
-          <a:lstStyle/>
-          <a:p>
-            <a:pPr algn="ctr"/>
-          </a:p>
-        </p:txBody>
-      </p:sp>
-      <p:sp>
-        <p:nvSpPr>
-          <p:cNvPr id="76" name="TextBox 75"/>
-          <p:cNvSpPr txBox="1"/>
-          <p:nvPr/>
-        </p:nvSpPr>
-        <p:spPr>
-          <a:xfrm>
-            <a:off x="9400032" y="2432304"/>
-            <a:ext cx="2359152" cy="274320"/>
-          </a:xfrm>
-          <a:prstGeom prst="rect">
-            <a:avLst/>
-          </a:prstGeom>
-          <a:noFill/>
-        </p:spPr>
-        <p:txBody>
-          <a:bodyPr wrap="square">
-            <a:spAutoFit/>
-          </a:bodyPr>
-          <a:lstStyle/>
-          <a:p>
-            <a:pPr algn="l"/>
-            <a:r>
-              <a:rPr sz="1800" b="1" i="0">
-                <a:solidFill>
-                  <a:srgbClr val="C9A84C"/>
-                </a:solidFill>
-              </a:rPr>
-              <a:t>BSP</a:t>
-            </a:r>
-          </a:p>
-        </p:txBody>
-      </p:sp>
-      <p:sp>
-        <p:nvSpPr>
-          <p:cNvPr id="77" name="TextBox 76"/>
-          <p:cNvSpPr txBox="1"/>
-          <p:nvPr/>
-        </p:nvSpPr>
-        <p:spPr>
-          <a:xfrm>
-            <a:off x="9400032" y="2706624"/>
-            <a:ext cx="2359152" cy="182880"/>
-          </a:xfrm>
-          <a:prstGeom prst="rect">
-            <a:avLst/>
-          </a:prstGeom>
-          <a:noFill/>
-        </p:spPr>
-        <p:txBody>
-          <a:bodyPr wrap="square">
-            <a:spAutoFit/>
-          </a:bodyPr>
-          <a:lstStyle/>
-          <a:p>
-            <a:pPr algn="l"/>
-            <a:r>
-              <a:rPr sz="950" b="1" i="0">
-                <a:solidFill>
-                  <a:srgbClr val="C9A84C"/>
-                </a:solidFill>
-              </a:rPr>
-              <a:t>BUILDER SPRINT</a:t>
-            </a:r>
-          </a:p>
-        </p:txBody>
-      </p:sp>
-      <p:sp>
-        <p:nvSpPr>
-          <p:cNvPr id="78" name="TextBox 77"/>
-          <p:cNvSpPr txBox="1"/>
-          <p:nvPr/>
-        </p:nvSpPr>
-        <p:spPr>
-          <a:xfrm>
-            <a:off x="9400032" y="2935224"/>
-            <a:ext cx="2359152" cy="1856232"/>
-          </a:xfrm>
-          <a:prstGeom prst="rect">
-            <a:avLst/>
-          </a:prstGeom>
-          <a:noFill/>
-        </p:spPr>
-        <p:txBody>
-          <a:bodyPr wrap="square">
-            <a:spAutoFit/>
-          </a:bodyPr>
-          <a:lstStyle/>
-          <a:p>
-            <a:pPr algn="l"/>
-            <a:r>
-              <a:rPr sz="900" b="0" i="0">
-                <a:solidFill>
-                  <a:srgbClr val="FFFFFF"/>
-                </a:solidFill>
-              </a:rPr>
-              <a:t>Quarterly · 5-day supervised
-build event
-Prereq: TM-20 Go
-+ command-validated project
-Does NOT grant TM-30 credit
-Does NOT unlock TM-40</a:t>
-            </a:r>
-          </a:p>
-        </p:txBody>
-      </p:sp>
-      <p:sp>
-        <p:nvSpPr>
-          <p:cNvPr id="79" name="TextBox 78"/>
-          <p:cNvSpPr txBox="1"/>
-          <p:nvPr/>
-        </p:nvSpPr>
-        <p:spPr>
-          <a:xfrm>
-            <a:off x="2560320" y="2688336"/>
-            <a:ext cx="365760" cy="164592"/>
-          </a:xfrm>
-          <a:prstGeom prst="rect">
-            <a:avLst/>
-          </a:prstGeom>
-          <a:noFill/>
-        </p:spPr>
-        <p:txBody>
-          <a:bodyPr wrap="square">
-            <a:spAutoFit/>
-          </a:bodyPr>
-          <a:lstStyle/>
-          <a:p>
-            <a:pPr algn="l"/>
-            <a:r>
-              <a:rPr sz="700" b="0" i="1">
-                <a:solidFill>
-                  <a:srgbClr val="888888"/>
-                </a:solidFill>
-              </a:rPr>
-              <a:t>parallel track</a:t>
-            </a:r>
-          </a:p>
-        </p:txBody>
-      </p:sp>
-      <p:sp>
-        <p:nvSpPr>
-          <p:cNvPr id="80" name="TextBox 79"/>
-          <p:cNvSpPr txBox="1"/>
-          <p:nvPr/>
-        </p:nvSpPr>
-        <p:spPr>
-          <a:xfrm>
-            <a:off x="320040" y="5029200"/>
-            <a:ext cx="8695944" cy="219456"/>
-          </a:xfrm>
-          <a:prstGeom prst="rect">
-            <a:avLst/>
-          </a:prstGeom>
-          <a:noFill/>
-        </p:spPr>
-        <p:txBody>
-          <a:bodyPr wrap="square">
-            <a:spAutoFit/>
-          </a:bodyPr>
-          <a:lstStyle/>
-          <a:p>
-            <a:pPr algn="ctr"/>
-            <a:r>
-              <a:rPr sz="850" b="0" i="1">
-                <a:solidFill>
-                  <a:srgbClr val="444444"/>
-                </a:solidFill>
-              </a:rPr>
-              <a:t>TM-40 / TM-50  —  21 specialist &amp; advanced tracks published and ready  (WFF: Intel · Fires · M&amp;M · Sustainment · Protection · MC  |  Technical: ORSA · AI · ML · PM · KM · SWE)  —  Execution follows TM-10/20/30 baseline</a:t>
-            </a:r>
-          </a:p>
-        </p:txBody>
-      </p:sp>
+      </p:pic>
     </p:spTree>
-    <p:extLst>
-      <p:ext uri="{BB962C8B-B14F-4D97-AF65-F5344CB8AC3E}">
-        <p14:creationId xmlns:p14="http://schemas.microsoft.com/office/powerpoint/2010/main" val="229586251"/>
-      </p:ext>
-    </p:extLst>
   </p:cSld>
   <p:clrMapOvr>
     <a:masterClrMapping/>

</xml_diff>